<commit_message>
Week 4 notebook: one rule, two contexts, and far less prose
The notebook now teaches a single idea and uses it twice. Same context,
pull together; different context, push apart. For a word a context is a
few words of text; for a painting it is the caption that belongs to it.

Part 1c is new and it runs: the picture features from the convolution
section and a bag of words over the Met titles get a matrix each, trained
together so a painting lands next to its own caption and away from
everyone else's. Then you type "a young man in a hat" and it returns two
young men in hats. Eighteen pairs is small enough to memorise and the
notebook says so, but the shape is real, and it is CLIP.

Prose cut throughout: every markdown cell is now a few lines, and the
chatty code comments are one line each.

Co-Authored-By: Claude Opus 5 <noreply@anthropic.com>
Claude-Session: https://claude.ai/code/session_019zyD3od7wiSyuKJ3rsod35
</commit_message>
<xml_diff>
--- a/slides/week-04-lecture-draft.pptx
+++ b/slides/week-04-lecture-draft.pptx
@@ -4176,7 +4176,7 @@
                 <a:ea typeface="Cambria" pitchFamily="34" charset="-122"/>
                 <a:cs typeface="Cambria" pitchFamily="34" charset="-120"/>
               </a:rPr>
-              <a:t>Pull the neighbours together, push the strangers apart</a:t>
+              <a:t>Same context, pull together. Different, push apart</a:t>
             </a:r>
             <a:endParaRPr lang="en-US" sz="3400" dirty="0"/>
           </a:p>
@@ -4238,7 +4238,7 @@
                 <a:ea typeface="Cambria" pitchFamily="34" charset="-122"/>
                 <a:cs typeface="Cambria" pitchFamily="34" charset="-120"/>
               </a:rPr>
-              <a:t>That is the whole training rule. It has a name — contrastive learning — and it is how most modern embeddings are made.</a:t>
+              <a:t>For a word, a context is a few words of text. That is the whole rule, it is called contrastive learning, and it is how most modern embeddings are made.</a:t>
             </a:r>
             <a:endParaRPr lang="en-US" sz="1600" dirty="0"/>
           </a:p>
@@ -7371,7 +7371,7 @@
                 <a:ea typeface="Cambria" pitchFamily="34" charset="-122"/>
                 <a:cs typeface="Cambria" pitchFamily="34" charset="-120"/>
               </a:rPr>
-              <a:t>CLIP: the same pull and push, on pictures</a:t>
+              <a:t>The same rule, where a context is a picture</a:t>
             </a:r>
             <a:endParaRPr lang="en-US" sz="3400" dirty="0"/>
           </a:p>
@@ -7433,7 +7433,7 @@
                 <a:ea typeface="Cambria" pitchFamily="34" charset="-122"/>
                 <a:cs typeface="Cambria" pitchFamily="34" charset="-120"/>
               </a:rPr>
-              <a:t>A CNN reads the picture, a language model reads the caption, and the training rule is the one from the word vectors.</a:t>
+              <a:t>Same context: a painting and its own caption, pulled together. Different context: anyone else's caption, pushed away. Two kinds of thing, one space.</a:t>
             </a:r>
             <a:endParaRPr lang="en-US" sz="1600" dirty="0"/>
           </a:p>
@@ -7472,7 +7472,7 @@
                 <a:ea typeface="Calibri" pitchFamily="34" charset="-122"/>
                 <a:cs typeface="Calibri" pitchFamily="34" charset="-120"/>
               </a:rPr>
-              <a:t>Which is why "a painting of a woman in a red hat" can search a museum with no tags in it at all.</a:t>
+              <a:t>Which is why "a painting of a woman in a red hat" can search a museum with no tags in it at all. The notebook trains a small one on 18 paintings.</a:t>
             </a:r>
             <a:endParaRPr lang="en-US" sz="1000" dirty="0"/>
           </a:p>

</xml_diff>

<commit_message>
Week 4: plainer wording in the notebook and the deck
Same content, fewer flourishes. Cut the aphoristic closers, the triple
parallels and most of the dashes, and said the plain thing instead.

Co-Authored-By: Claude Opus 5 <noreply@anthropic.com>
Claude-Session: https://claude.ai/code/session_019zyD3od7wiSyuKJ3rsod35
</commit_message>
<xml_diff>
--- a/slides/week-04-lecture-draft.pptx
+++ b/slides/week-04-lecture-draft.pptx
@@ -4238,7 +4238,7 @@
                 <a:ea typeface="Cambria" pitchFamily="34" charset="-122"/>
                 <a:cs typeface="Cambria" pitchFamily="34" charset="-120"/>
               </a:rPr>
-              <a:t>For a word, a context is a few words of text. That is the whole rule, it is called contrastive learning, and it is how most modern embeddings are made.</a:t>
+              <a:t>For a word, a context is a few words of text. That is the whole rule. It is called contrastive learning, and most modern embeddings are trained this way.</a:t>
             </a:r>
             <a:endParaRPr lang="en-US" sz="1600" dirty="0"/>
           </a:p>
@@ -4449,7 +4449,7 @@
                 <a:ea typeface="Cambria" pitchFamily="34" charset="-122"/>
                 <a:cs typeface="Cambria" pitchFamily="34" charset="-120"/>
               </a:rPr>
-              <a:t>Twelve words, every pair compared. On the left they start as noise; on the right, times of day, family and rooms have found each other.</a:t>
+              <a:t>Twelve words, every pair compared. On the left they start as noise. On the right, times of day, family and rooms have found each other.</a:t>
             </a:r>
             <a:endParaRPr lang="en-US" sz="1600" dirty="0"/>
           </a:p>
@@ -5736,7 +5736,7 @@
                 <a:ea typeface="Cambria" pitchFamily="34" charset="-122"/>
                 <a:cs typeface="Cambria" pitchFamily="34" charset="-120"/>
               </a:rPr>
-              <a:t>A picture is a grid of numbers. Take nine of them, multiply by nine other numbers, add: -162. Slide one step and do it again.</a:t>
+              <a:t>A picture is a grid of numbers. Take nine of them, multiply by nine other numbers, add them up: -162. Move one pixel across and repeat.</a:t>
             </a:r>
             <a:endParaRPr lang="en-US" sz="1600" dirty="0"/>
           </a:p>
@@ -7050,7 +7050,7 @@
                 <a:ea typeface="Calibri" pitchFamily="34" charset="-122"/>
                 <a:cs typeface="Calibri" pitchFamily="34" charset="-120"/>
               </a:rPr>
-              <a:t>A CNN is not given these. It starts with random grids and learns which ones are worth having — same downhill roll as before.</a:t>
+              <a:t>A CNN is not given these. It starts with random grids and learns which ones are worth having, by the same downhill roll as before.</a:t>
             </a:r>
             <a:endParaRPr lang="en-US" sz="1000" dirty="0"/>
           </a:p>
@@ -7222,7 +7222,7 @@
                 <a:ea typeface="Cambria" pitchFamily="34" charset="-122"/>
                 <a:cs typeface="Cambria" pitchFamily="34" charset="-120"/>
               </a:rPr>
-              <a:t>Run a filter on the answers of the last filter, and shrink. Edges become corners; corners become regions; regions become faces.</a:t>
+              <a:t>Run a filter over the output of the last filter, then shrink. Edges turn into corners, and corners into regions.</a:t>
             </a:r>
             <a:endParaRPr lang="en-US" sz="1600" dirty="0"/>
           </a:p>
@@ -7261,7 +7261,7 @@
                 <a:ea typeface="Calibri" pitchFamily="34" charset="-122"/>
                 <a:cs typeface="Calibri" pitchFamily="34" charset="-120"/>
               </a:rPr>
-              <a:t>Every panel here is real arithmetic on the painting to its left. That stack is the whole architecture.</a:t>
+              <a:t>Every panel is real arithmetic on the painting to its left. Stacking them is all a CNN is.</a:t>
             </a:r>
             <a:endParaRPr lang="en-US" sz="1000" dirty="0"/>
           </a:p>
@@ -7433,7 +7433,7 @@
                 <a:ea typeface="Cambria" pitchFamily="34" charset="-122"/>
                 <a:cs typeface="Cambria" pitchFamily="34" charset="-120"/>
               </a:rPr>
-              <a:t>Same context: a painting and its own caption, pulled together. Different context: anyone else's caption, pushed away. Two kinds of thing, one space.</a:t>
+              <a:t>Same context: a painting and its own caption, pulled together. Different context: anyone else's caption, pushed away. Two kinds of thing in one space.</a:t>
             </a:r>
             <a:endParaRPr lang="en-US" sz="1600" dirty="0"/>
           </a:p>
@@ -11310,7 +11310,7 @@
                 <a:ea typeface="Cambria" pitchFamily="34" charset="-122"/>
                 <a:cs typeface="Cambria" pitchFamily="34" charset="-120"/>
               </a:rPr>
-              <a:t>Four neurons in between, each adding up every word in its own way. Nobody wrote those combinations down.</a:t>
+              <a:t>Four neurons in between, each adding up every word in its own way. Nobody chose those combinations.</a:t>
             </a:r>
             <a:endParaRPr lang="en-US" sz="1600" dirty="0"/>
           </a:p>
@@ -11482,7 +11482,7 @@
                 <a:ea typeface="Cambria" pitchFamily="34" charset="-122"/>
                 <a:cs typeface="Cambria" pitchFamily="34" charset="-120"/>
               </a:rPr>
-              <a:t>Same passages, same job: 100% against 99%. The left panel is an explanation. The right one is not.</a:t>
+              <a:t>Same passages, same job: 100% against 99%. You can read the left panel and say why. You cannot do that with the right one.</a:t>
             </a:r>
             <a:endParaRPr lang="en-US" sz="1600" dirty="0"/>
           </a:p>

</xml_diff>

<commit_message>
Week 4: say why embeddings, and tie them back to counting and Week 3
The notebook now opens on the problem instead of the method. Three words
as a bag of words, father . mother = 0 and father . table = 0, so counting
cannot tell them apart and a classifier with one weight per column cannot
generalise from one to the next. After training, the same two pairs read
+0.42 and -0.01.

Also names what the training loop is: Week 3's four moves, multiply, add,
squash, nudge, with the prediction thrown away and the weights kept. Same
thing the hidden layer was doing a lecture earlier.

Deck, lesson plan and week page carry the same two connections.

Co-Authored-By: Claude Opus 5 <noreply@anthropic.com>
Claude-Session: https://claude.ai/code/session_019zyD3od7wiSyuKJ3rsod35
</commit_message>
<xml_diff>
--- a/slides/week-04-lecture-draft.pptx
+++ b/slides/week-04-lecture-draft.pptx
@@ -4066,9 +4066,48 @@
                 <a:ea typeface="Cambria" pitchFamily="34" charset="-122"/>
                 <a:cs typeface="Cambria" pitchFamily="34" charset="-120"/>
               </a:rPr>
-              <a:t>Counting says night and morning have nothing in common. The trained vectors put them at 0.32, against 0.08 for night and ship.</a:t>
+              <a:t>Week 2 gave every word its own column, so night and morning have nothing in common. Nor do night and ship.</a:t>
             </a:r>
             <a:endParaRPr lang="en-US" sz="1600" dirty="0"/>
+          </a:p>
+        </p:txBody>
+      </p:sp>
+      <p:sp>
+        <p:nvSpPr>
+          <p:cNvPr id="6" name="Text 3"/>
+          <p:cNvSpPr/>
+          <p:nvPr/>
+        </p:nvSpPr>
+        <p:spPr>
+          <a:xfrm>
+            <a:off x="640080" y="6355080"/>
+            <a:ext cx="10881360" cy="320040"/>
+          </a:xfrm>
+          <a:prstGeom prst="rect">
+            <a:avLst/>
+          </a:prstGeom>
+          <a:noFill/>
+          <a:ln/>
+        </p:spPr>
+        <p:txBody>
+          <a:bodyPr wrap="square" rtlCol="0" anchor="ctr"/>
+          <a:lstStyle/>
+          <a:p>
+            <a:pPr indent="0" marL="0">
+              <a:buNone/>
+            </a:pPr>
+            <a:r>
+              <a:rPr lang="en-US" sz="1000" dirty="0">
+                <a:solidFill>
+                  <a:srgbClr val="6B6B63"/>
+                </a:solidFill>
+                <a:latin typeface="Calibri" pitchFamily="34" charset="0"/>
+                <a:ea typeface="Calibri" pitchFamily="34" charset="-122"/>
+                <a:cs typeface="Calibri" pitchFamily="34" charset="-120"/>
+              </a:rPr>
+              <a:t>And Week 3 puts one weight on each column, so what it learns about one word tells it nothing about the next. Trained vectors: night and morning 0.32, night and ship 0.08.</a:t>
+            </a:r>
+            <a:endParaRPr lang="en-US" sz="1000" dirty="0"/>
           </a:p>
         </p:txBody>
       </p:sp>
@@ -4277,7 +4316,7 @@
                 <a:ea typeface="Calibri" pitchFamily="34" charset="-122"/>
                 <a:cs typeface="Calibri" pitchFamily="34" charset="-120"/>
               </a:rPr>
-              <a:t>Anchor, neighbour and the three random words all taken from this week's corpus. 849,738 pairs in one pass.</a:t>
+              <a:t>Underneath it, Week 3's four moves: multiply, add, squash, nudge. The difference is that the prediction is thrown away and the weights are what you keep. 849,738 pairs in one pass.</a:t>
             </a:r>
             <a:endParaRPr lang="en-US" sz="1000" dirty="0"/>
           </a:p>

</xml_diff>

<commit_message>
Week 4 deck: give data collection the same weight as the models
Four new figures, all built from live calls. The request beside the reply,
with the pagination block called out as the thing to read first. The Art
Institute and the Met drawn side by side, one handing you 100 rows for one
request and the other handing you 157 ID numbers plus 157 more requests.
One real quote block of HTML with its three selectors marked and the row
they produce. And what a one-second pause actually costs: 5,000 pages is
an hour and a half, which is the number that decides your sample size.

The arc slide now reads as four ideas and two collecting sessions rather
than four and one.

Co-Authored-By: Claude Opus 5 <noreply@anthropic.com>
Claude-Session: https://claude.ai/code/session_019zyD3od7wiSyuKJ3rsod35
</commit_message>
<xml_diff>
--- a/slides/week-04-lecture-draft.pptx
+++ b/slides/week-04-lecture-draft.pptx
@@ -33,9 +33,13 @@
     <p:sldId id="281" r:id="rId27"/>
     <p:sldId id="282" r:id="rId28"/>
     <p:sldId id="283" r:id="rId29"/>
+    <p:sldId id="284" r:id="rId30"/>
+    <p:sldId id="285" r:id="rId31"/>
+    <p:sldId id="286" r:id="rId32"/>
+    <p:sldId id="287" r:id="rId33"/>
   </p:sldIdLst>
   <p:notesMasterIdLst>
-    <p:notesMasterId r:id="rId30"/>
+    <p:notesMasterId r:id="rId34"/>
   </p:notesMasterIdLst>
   <p:sldSz cx="12191695" cy="6858000"/>
   <p:notesSz cx="6858000" cy="12191695"/>
@@ -2331,6 +2335,94 @@
 </p:notes>
 </file>
 
+<file path=ppt/notesSlides/notesSlide29.xml><?xml version="1.0" encoding="utf-8"?>
+<p:notes xmlns:a="http://schemas.openxmlformats.org/drawingml/2006/main" xmlns:r="http://schemas.openxmlformats.org/officeDocument/2006/relationships" xmlns:p="http://schemas.openxmlformats.org/presentationml/2006/main">
+  <p:cSld>
+    <p:spTree>
+      <p:nvGrpSpPr>
+        <p:cNvPr id="1" name=""/>
+        <p:cNvGrpSpPr/>
+        <p:nvPr/>
+      </p:nvGrpSpPr>
+      <p:grpSpPr>
+        <a:xfrm>
+          <a:off x="0" y="0"/>
+          <a:ext cx="0" cy="0"/>
+          <a:chOff x="0" y="0"/>
+          <a:chExt cx="0" cy="0"/>
+        </a:xfrm>
+      </p:grpSpPr>
+      <p:sp>
+        <p:nvSpPr>
+          <p:cNvPr id="2" name="Slide Image Placeholder 1"/>
+          <p:cNvSpPr>
+            <a:spLocks noGrp="1" noRot="1" noChangeAspect="1"/>
+          </p:cNvSpPr>
+          <p:nvPr>
+            <p:ph type="sldImg"/>
+          </p:nvPr>
+        </p:nvSpPr>
+        <p:spPr/>
+      </p:sp>
+      <p:sp>
+        <p:nvSpPr>
+          <p:cNvPr id="3" name="Notes Placeholder 2"/>
+          <p:cNvSpPr>
+            <a:spLocks noGrp="1"/>
+          </p:cNvSpPr>
+          <p:nvPr>
+            <p:ph type="body" idx="1"/>
+          </p:nvPr>
+        </p:nvSpPr>
+        <p:spPr/>
+        <p:txBody>
+          <a:bodyPr/>
+          <a:lstStyle/>
+          <a:p>
+            <a:r>
+              <a:rPr lang="en-US" dirty="0"/>
+              <a:t/>
+            </a:r>
+            <a:endParaRPr lang="en-US" dirty="0"/>
+          </a:p>
+        </p:txBody>
+      </p:sp>
+      <p:sp>
+        <p:nvSpPr>
+          <p:cNvPr id="4" name="Slide Number Placeholder 3"/>
+          <p:cNvSpPr>
+            <a:spLocks noGrp="1"/>
+          </p:cNvSpPr>
+          <p:nvPr>
+            <p:ph type="sldNum" sz="quarter" idx="10"/>
+          </p:nvPr>
+        </p:nvSpPr>
+        <p:spPr/>
+        <p:txBody>
+          <a:bodyPr/>
+          <a:lstStyle/>
+          <a:p>
+            <a:fld id="{F7021451-1387-4CA6-816F-3879F97B5CBC}" type="slidenum">
+              <a:rPr lang="en-US"/>
+              <a:t>29</a:t>
+            </a:fld>
+            <a:endParaRPr lang="en-US"/>
+          </a:p>
+        </p:txBody>
+      </p:sp>
+    </p:spTree>
+    <p:extLst>
+      <p:ext uri="{BB962C8B-B14F-4D97-AF65-F5344CB8AC3E}">
+        <p14:creationId xmlns:p14="http://schemas.microsoft.com/office/powerpoint/2010/main" val="1024086991"/>
+      </p:ext>
+    </p:extLst>
+  </p:cSld>
+  <p:clrMapOvr>
+    <a:masterClrMapping/>
+  </p:clrMapOvr>
+</p:notes>
+</file>
+
 <file path=ppt/notesSlides/notesSlide3.xml><?xml version="1.0" encoding="utf-8"?>
 <p:notes xmlns:a="http://schemas.openxmlformats.org/drawingml/2006/main" xmlns:r="http://schemas.openxmlformats.org/officeDocument/2006/relationships" xmlns:p="http://schemas.openxmlformats.org/presentationml/2006/main">
   <p:cSld>
@@ -2401,6 +2493,270 @@
             <a:fld id="{F7021451-1387-4CA6-816F-3879F97B5CBC}" type="slidenum">
               <a:rPr lang="en-US"/>
               <a:t>3</a:t>
+            </a:fld>
+            <a:endParaRPr lang="en-US"/>
+          </a:p>
+        </p:txBody>
+      </p:sp>
+    </p:spTree>
+    <p:extLst>
+      <p:ext uri="{BB962C8B-B14F-4D97-AF65-F5344CB8AC3E}">
+        <p14:creationId xmlns:p14="http://schemas.microsoft.com/office/powerpoint/2010/main" val="1024086991"/>
+      </p:ext>
+    </p:extLst>
+  </p:cSld>
+  <p:clrMapOvr>
+    <a:masterClrMapping/>
+  </p:clrMapOvr>
+</p:notes>
+</file>
+
+<file path=ppt/notesSlides/notesSlide30.xml><?xml version="1.0" encoding="utf-8"?>
+<p:notes xmlns:a="http://schemas.openxmlformats.org/drawingml/2006/main" xmlns:r="http://schemas.openxmlformats.org/officeDocument/2006/relationships" xmlns:p="http://schemas.openxmlformats.org/presentationml/2006/main">
+  <p:cSld>
+    <p:spTree>
+      <p:nvGrpSpPr>
+        <p:cNvPr id="1" name=""/>
+        <p:cNvGrpSpPr/>
+        <p:nvPr/>
+      </p:nvGrpSpPr>
+      <p:grpSpPr>
+        <a:xfrm>
+          <a:off x="0" y="0"/>
+          <a:ext cx="0" cy="0"/>
+          <a:chOff x="0" y="0"/>
+          <a:chExt cx="0" cy="0"/>
+        </a:xfrm>
+      </p:grpSpPr>
+      <p:sp>
+        <p:nvSpPr>
+          <p:cNvPr id="2" name="Slide Image Placeholder 1"/>
+          <p:cNvSpPr>
+            <a:spLocks noGrp="1" noRot="1" noChangeAspect="1"/>
+          </p:cNvSpPr>
+          <p:nvPr>
+            <p:ph type="sldImg"/>
+          </p:nvPr>
+        </p:nvSpPr>
+        <p:spPr/>
+      </p:sp>
+      <p:sp>
+        <p:nvSpPr>
+          <p:cNvPr id="3" name="Notes Placeholder 2"/>
+          <p:cNvSpPr>
+            <a:spLocks noGrp="1"/>
+          </p:cNvSpPr>
+          <p:nvPr>
+            <p:ph type="body" idx="1"/>
+          </p:nvPr>
+        </p:nvSpPr>
+        <p:spPr/>
+        <p:txBody>
+          <a:bodyPr/>
+          <a:lstStyle/>
+          <a:p>
+            <a:r>
+              <a:rPr lang="en-US" dirty="0"/>
+              <a:t/>
+            </a:r>
+            <a:endParaRPr lang="en-US" dirty="0"/>
+          </a:p>
+        </p:txBody>
+      </p:sp>
+      <p:sp>
+        <p:nvSpPr>
+          <p:cNvPr id="4" name="Slide Number Placeholder 3"/>
+          <p:cNvSpPr>
+            <a:spLocks noGrp="1"/>
+          </p:cNvSpPr>
+          <p:nvPr>
+            <p:ph type="sldNum" sz="quarter" idx="10"/>
+          </p:nvPr>
+        </p:nvSpPr>
+        <p:spPr/>
+        <p:txBody>
+          <a:bodyPr/>
+          <a:lstStyle/>
+          <a:p>
+            <a:fld id="{F7021451-1387-4CA6-816F-3879F97B5CBC}" type="slidenum">
+              <a:rPr lang="en-US"/>
+              <a:t>30</a:t>
+            </a:fld>
+            <a:endParaRPr lang="en-US"/>
+          </a:p>
+        </p:txBody>
+      </p:sp>
+    </p:spTree>
+    <p:extLst>
+      <p:ext uri="{BB962C8B-B14F-4D97-AF65-F5344CB8AC3E}">
+        <p14:creationId xmlns:p14="http://schemas.microsoft.com/office/powerpoint/2010/main" val="1024086991"/>
+      </p:ext>
+    </p:extLst>
+  </p:cSld>
+  <p:clrMapOvr>
+    <a:masterClrMapping/>
+  </p:clrMapOvr>
+</p:notes>
+</file>
+
+<file path=ppt/notesSlides/notesSlide31.xml><?xml version="1.0" encoding="utf-8"?>
+<p:notes xmlns:a="http://schemas.openxmlformats.org/drawingml/2006/main" xmlns:r="http://schemas.openxmlformats.org/officeDocument/2006/relationships" xmlns:p="http://schemas.openxmlformats.org/presentationml/2006/main">
+  <p:cSld>
+    <p:spTree>
+      <p:nvGrpSpPr>
+        <p:cNvPr id="1" name=""/>
+        <p:cNvGrpSpPr/>
+        <p:nvPr/>
+      </p:nvGrpSpPr>
+      <p:grpSpPr>
+        <a:xfrm>
+          <a:off x="0" y="0"/>
+          <a:ext cx="0" cy="0"/>
+          <a:chOff x="0" y="0"/>
+          <a:chExt cx="0" cy="0"/>
+        </a:xfrm>
+      </p:grpSpPr>
+      <p:sp>
+        <p:nvSpPr>
+          <p:cNvPr id="2" name="Slide Image Placeholder 1"/>
+          <p:cNvSpPr>
+            <a:spLocks noGrp="1" noRot="1" noChangeAspect="1"/>
+          </p:cNvSpPr>
+          <p:nvPr>
+            <p:ph type="sldImg"/>
+          </p:nvPr>
+        </p:nvSpPr>
+        <p:spPr/>
+      </p:sp>
+      <p:sp>
+        <p:nvSpPr>
+          <p:cNvPr id="3" name="Notes Placeholder 2"/>
+          <p:cNvSpPr>
+            <a:spLocks noGrp="1"/>
+          </p:cNvSpPr>
+          <p:nvPr>
+            <p:ph type="body" idx="1"/>
+          </p:nvPr>
+        </p:nvSpPr>
+        <p:spPr/>
+        <p:txBody>
+          <a:bodyPr/>
+          <a:lstStyle/>
+          <a:p>
+            <a:r>
+              <a:rPr lang="en-US" dirty="0"/>
+              <a:t/>
+            </a:r>
+            <a:endParaRPr lang="en-US" dirty="0"/>
+          </a:p>
+        </p:txBody>
+      </p:sp>
+      <p:sp>
+        <p:nvSpPr>
+          <p:cNvPr id="4" name="Slide Number Placeholder 3"/>
+          <p:cNvSpPr>
+            <a:spLocks noGrp="1"/>
+          </p:cNvSpPr>
+          <p:nvPr>
+            <p:ph type="sldNum" sz="quarter" idx="10"/>
+          </p:nvPr>
+        </p:nvSpPr>
+        <p:spPr/>
+        <p:txBody>
+          <a:bodyPr/>
+          <a:lstStyle/>
+          <a:p>
+            <a:fld id="{F7021451-1387-4CA6-816F-3879F97B5CBC}" type="slidenum">
+              <a:rPr lang="en-US"/>
+              <a:t>31</a:t>
+            </a:fld>
+            <a:endParaRPr lang="en-US"/>
+          </a:p>
+        </p:txBody>
+      </p:sp>
+    </p:spTree>
+    <p:extLst>
+      <p:ext uri="{BB962C8B-B14F-4D97-AF65-F5344CB8AC3E}">
+        <p14:creationId xmlns:p14="http://schemas.microsoft.com/office/powerpoint/2010/main" val="1024086991"/>
+      </p:ext>
+    </p:extLst>
+  </p:cSld>
+  <p:clrMapOvr>
+    <a:masterClrMapping/>
+  </p:clrMapOvr>
+</p:notes>
+</file>
+
+<file path=ppt/notesSlides/notesSlide32.xml><?xml version="1.0" encoding="utf-8"?>
+<p:notes xmlns:a="http://schemas.openxmlformats.org/drawingml/2006/main" xmlns:r="http://schemas.openxmlformats.org/officeDocument/2006/relationships" xmlns:p="http://schemas.openxmlformats.org/presentationml/2006/main">
+  <p:cSld>
+    <p:spTree>
+      <p:nvGrpSpPr>
+        <p:cNvPr id="1" name=""/>
+        <p:cNvGrpSpPr/>
+        <p:nvPr/>
+      </p:nvGrpSpPr>
+      <p:grpSpPr>
+        <a:xfrm>
+          <a:off x="0" y="0"/>
+          <a:ext cx="0" cy="0"/>
+          <a:chOff x="0" y="0"/>
+          <a:chExt cx="0" cy="0"/>
+        </a:xfrm>
+      </p:grpSpPr>
+      <p:sp>
+        <p:nvSpPr>
+          <p:cNvPr id="2" name="Slide Image Placeholder 1"/>
+          <p:cNvSpPr>
+            <a:spLocks noGrp="1" noRot="1" noChangeAspect="1"/>
+          </p:cNvSpPr>
+          <p:nvPr>
+            <p:ph type="sldImg"/>
+          </p:nvPr>
+        </p:nvSpPr>
+        <p:spPr/>
+      </p:sp>
+      <p:sp>
+        <p:nvSpPr>
+          <p:cNvPr id="3" name="Notes Placeholder 2"/>
+          <p:cNvSpPr>
+            <a:spLocks noGrp="1"/>
+          </p:cNvSpPr>
+          <p:nvPr>
+            <p:ph type="body" idx="1"/>
+          </p:nvPr>
+        </p:nvSpPr>
+        <p:spPr/>
+        <p:txBody>
+          <a:bodyPr/>
+          <a:lstStyle/>
+          <a:p>
+            <a:r>
+              <a:rPr lang="en-US" dirty="0"/>
+              <a:t/>
+            </a:r>
+            <a:endParaRPr lang="en-US" dirty="0"/>
+          </a:p>
+        </p:txBody>
+      </p:sp>
+      <p:sp>
+        <p:nvSpPr>
+          <p:cNvPr id="4" name="Slide Number Placeholder 3"/>
+          <p:cNvSpPr>
+            <a:spLocks noGrp="1"/>
+          </p:cNvSpPr>
+          <p:nvPr>
+            <p:ph type="sldNum" sz="quarter" idx="10"/>
+          </p:nvPr>
+        </p:nvSpPr>
+        <p:spPr/>
+        <p:txBody>
+          <a:bodyPr/>
+          <a:lstStyle/>
+          <a:p>
+            <a:fld id="{F7021451-1387-4CA6-816F-3879F97B5CBC}" type="slidenum">
+              <a:rPr lang="en-US"/>
+              <a:t>32</a:t>
             </a:fld>
             <a:endParaRPr lang="en-US"/>
           </a:p>
@@ -6285,7 +6641,7 @@
             <a:avLst/>
           </a:prstGeom>
           <a:solidFill>
-            <a:srgbClr val="2E5F8A"/>
+            <a:srgbClr val="B9852F"/>
           </a:solidFill>
           <a:ln/>
         </p:spPr>
@@ -6362,7 +6718,7 @@
                 <a:ea typeface="Calibri" pitchFamily="34" charset="-122"/>
                 <a:cs typeface="Calibri" pitchFamily="34" charset="-120"/>
               </a:rPr>
-              <a:t>Rolling downhill</a:t>
+              <a:t>Words as vectors</a:t>
             </a:r>
             <a:endParaRPr lang="en-US" sz="1600" dirty="0"/>
           </a:p>
@@ -6401,7 +6757,7 @@
                 <a:ea typeface="Calibri" pitchFamily="34" charset="-122"/>
                 <a:cs typeface="Calibri" pitchFamily="34" charset="-120"/>
               </a:rPr>
-              <a:t>What training actually is, without the calculus</a:t>
+              <a:t>Same context pull together, different context push apart</a:t>
             </a:r>
             <a:endParaRPr lang="en-US" sz="1250" dirty="0"/>
           </a:p>
@@ -6444,7 +6800,7 @@
             <a:avLst/>
           </a:prstGeom>
           <a:solidFill>
-            <a:srgbClr val="B9852F"/>
+            <a:srgbClr val="2E5F8A"/>
           </a:solidFill>
           <a:ln/>
         </p:spPr>
@@ -6521,7 +6877,7 @@
                 <a:ea typeface="Calibri" pitchFamily="34" charset="-122"/>
                 <a:cs typeface="Calibri" pitchFamily="34" charset="-120"/>
               </a:rPr>
-              <a:t>Words as vectors</a:t>
+              <a:t>The same rule on pixels</a:t>
             </a:r>
             <a:endParaRPr lang="en-US" sz="1600" dirty="0"/>
           </a:p>
@@ -6560,7 +6916,7 @@
                 <a:ea typeface="Calibri" pitchFamily="34" charset="-122"/>
                 <a:cs typeface="Calibri" pitchFamily="34" charset="-120"/>
               </a:rPr>
-              <a:t>Where they come from, and what the geometry can do</a:t>
+              <a:t>Convolutions, and how CLIP searches a museum by typing</a:t>
             </a:r>
             <a:endParaRPr lang="en-US" sz="1250" dirty="0"/>
           </a:p>
@@ -6680,7 +7036,7 @@
                 <a:ea typeface="Calibri" pitchFamily="34" charset="-122"/>
                 <a:cs typeface="Calibri" pitchFamily="34" charset="-120"/>
               </a:rPr>
-              <a:t>Where a corpus comes from</a:t>
+              <a:t>Reading an API</a:t>
             </a:r>
             <a:endParaRPr lang="en-US" sz="1600" dirty="0"/>
           </a:p>
@@ -6719,7 +7075,7 @@
                 <a:ea typeface="Calibri" pitchFamily="34" charset="-122"/>
                 <a:cs typeface="Calibri" pitchFamily="34" charset="-120"/>
               </a:rPr>
-              <a:t>A file, an API, or a careful scrape</a:t>
+              <a:t>What to look at before you write the loop</a:t>
             </a:r>
             <a:endParaRPr lang="en-US" sz="1250" dirty="0"/>
           </a:p>
@@ -6839,7 +7195,7 @@
                 <a:ea typeface="Calibri" pitchFamily="34" charset="-122"/>
                 <a:cs typeface="Calibri" pitchFamily="34" charset="-120"/>
               </a:rPr>
-              <a:t>Collect and commit</a:t>
+              <a:t>A careful scrape</a:t>
             </a:r>
             <a:endParaRPr lang="en-US" sz="1600" dirty="0"/>
           </a:p>
@@ -6878,7 +7234,7 @@
                 <a:ea typeface="Calibri" pitchFamily="34" charset="-122"/>
                 <a:cs typeface="Calibri" pitchFamily="34" charset="-120"/>
               </a:rPr>
-              <a:t>Your data in Drive, your repo born, your project pitched</a:t>
+              <a:t>Finding the data in a page, and the four rules attached</a:t>
             </a:r>
             <a:endParaRPr lang="en-US" sz="1250" dirty="0"/>
           </a:p>
@@ -8357,7 +8713,7 @@
                 <a:ea typeface="Calibri" pitchFamily="34" charset="-122"/>
                 <a:cs typeface="Calibri" pitchFamily="34" charset="-120"/>
               </a:rPr>
-              <a:t>ROUTE TWO, LIVE</a:t>
+              <a:t>ROUTE TWO</a:t>
             </a:r>
             <a:endParaRPr lang="en-US" sz="1300" dirty="0"/>
           </a:p>
@@ -8396,7 +8752,7 @@
                 <a:ea typeface="Cambria" pitchFamily="34" charset="-122"/>
                 <a:cs typeface="Cambria" pitchFamily="34" charset="-120"/>
               </a:rPr>
-              <a:t>A URL, some JSON, and then a table</a:t>
+              <a:t>Look at one reply before you write the loop</a:t>
             </a:r>
             <a:endParaRPr lang="en-US" sz="3400" dirty="0"/>
           </a:p>
@@ -8404,7 +8760,7 @@
       </p:sp>
       <p:pic>
         <p:nvPicPr>
-          <p:cNvPr id="4" name="Image 0" descr="/tmp/figs/w4_api.png">    </p:cNvPr>
+          <p:cNvPr id="4" name="Image 0" descr="/tmp/figs/w4_api_anatomy.png">    </p:cNvPr>
           <p:cNvPicPr>
             <a:picLocks noChangeAspect="1"/>
           </p:cNvPicPr>
@@ -8417,8 +8773,8 @@
         </p:blipFill>
         <p:spPr>
           <a:xfrm>
-            <a:off x="1097280" y="1920240"/>
-            <a:ext cx="9966960" cy="3749040"/>
+            <a:off x="640080" y="1874520"/>
+            <a:ext cx="10881360" cy="3566160"/>
           </a:xfrm>
           <a:prstGeom prst="rect">
             <a:avLst/>
@@ -8458,7 +8814,7 @@
                 <a:ea typeface="Cambria" pitchFamily="34" charset="-122"/>
                 <a:cs typeface="Cambria" pitchFamily="34" charset="-120"/>
               </a:rPr>
-              <a:t>An endpoint is a URL that answers with data. A key is a name badge. Pagination hands you a page at a time.</a:t>
+              <a:t>Ask for one item. The pagination block tells you how big the job is; the data block is your rows.</a:t>
             </a:r>
             <a:endParaRPr lang="en-US" sz="1600" dirty="0"/>
           </a:p>
@@ -8497,7 +8853,7 @@
                 <a:ea typeface="Calibri" pitchFamily="34" charset="-122"/>
                 <a:cs typeface="Calibri" pitchFamily="34" charset="-120"/>
               </a:rPr>
-              <a:t>Left panel: a real response, live from api.artic.edu. The AI writes the three lines that make the table.</a:t>
+              <a:t>A live call made while this deck was built: 132,681 works match "landscape", handed over two at a time.</a:t>
             </a:r>
             <a:endParaRPr lang="en-US" sz="1000" dirty="0"/>
           </a:p>
@@ -8562,13 +8918,13 @@
             <a:r>
               <a:rPr lang="en-US" sz="1300" b="1" spc="300" kern="0" dirty="0">
                 <a:solidFill>
-                  <a:srgbClr val="7A3B2E"/>
+                  <a:srgbClr val="2E5F8A"/>
                 </a:solidFill>
                 <a:latin typeface="Calibri" pitchFamily="34" charset="0"/>
                 <a:ea typeface="Calibri" pitchFamily="34" charset="-122"/>
                 <a:cs typeface="Calibri" pitchFamily="34" charset="-120"/>
               </a:rPr>
-              <a:t>ROUTE THREE</a:t>
+              <a:t>ROUTE TWO, LIVE</a:t>
             </a:r>
             <a:endParaRPr lang="en-US" sz="1300" dirty="0"/>
           </a:p>
@@ -8607,448 +8963,110 @@
                 <a:ea typeface="Cambria" pitchFamily="34" charset="-122"/>
                 <a:cs typeface="Cambria" pitchFamily="34" charset="-120"/>
               </a:rPr>
-              <a:t>Scraping, and the four things that come with it</a:t>
+              <a:t>A URL, some JSON, and then a table</a:t>
             </a:r>
             <a:endParaRPr lang="en-US" sz="3400" dirty="0"/>
           </a:p>
         </p:txBody>
       </p:sp>
-      <p:sp>
-        <p:nvSpPr>
-          <p:cNvPr id="4" name="Shape 2"/>
-          <p:cNvSpPr/>
-          <p:nvPr/>
-        </p:nvSpPr>
-        <p:spPr>
-          <a:xfrm>
-            <a:off x="640080" y="2011680"/>
-            <a:ext cx="10881360" cy="914400"/>
-          </a:xfrm>
-          <a:prstGeom prst="roundRect">
-            <a:avLst>
-              <a:gd name="adj" fmla="val 10000"/>
-            </a:avLst>
-          </a:prstGeom>
-          <a:solidFill>
-            <a:srgbClr val="F4EEE8"/>
-          </a:solidFill>
-          <a:ln/>
-        </p:spPr>
-      </p:sp>
-      <p:sp>
-        <p:nvSpPr>
-          <p:cNvPr id="5" name="Text 3"/>
-          <p:cNvSpPr/>
-          <p:nvPr/>
-        </p:nvSpPr>
-        <p:spPr>
-          <a:xfrm>
-            <a:off x="960120" y="2103120"/>
-            <a:ext cx="4023360" cy="731520"/>
-          </a:xfrm>
-          <a:prstGeom prst="rect">
-            <a:avLst/>
-          </a:prstGeom>
-          <a:noFill/>
-          <a:ln/>
-        </p:spPr>
-        <p:txBody>
-          <a:bodyPr wrap="square" lIns="0" tIns="0" rIns="0" bIns="0" rtlCol="0" anchor="ctr"/>
-          <a:lstStyle/>
-          <a:p>
-            <a:pPr indent="0" marL="0">
-              <a:buNone/>
-            </a:pPr>
-            <a:r>
-              <a:rPr lang="en-US" sz="1700" b="1" dirty="0">
-                <a:solidFill>
-                  <a:srgbClr val="7A3B2E"/>
+      <p:pic>
+        <p:nvPicPr>
+          <p:cNvPr id="4" name="Image 0" descr="/tmp/figs/w4_api.png">    </p:cNvPr>
+          <p:cNvPicPr>
+            <a:picLocks noChangeAspect="1"/>
+          </p:cNvPicPr>
+          <p:nvPr/>
+        </p:nvPicPr>
+        <p:blipFill>
+          <a:blip r:embed="rId1"/>
+          <a:srcRect l="0" r="0" t="0" b="0"/>
+          <a:stretch/>
+        </p:blipFill>
+        <p:spPr>
+          <a:xfrm>
+            <a:off x="1097280" y="1920240"/>
+            <a:ext cx="9966960" cy="3749040"/>
+          </a:xfrm>
+          <a:prstGeom prst="rect">
+            <a:avLst/>
+          </a:prstGeom>
+        </p:spPr>
+      </p:pic>
+      <p:sp>
+        <p:nvSpPr>
+          <p:cNvPr id="5" name="Text 2"/>
+          <p:cNvSpPr/>
+          <p:nvPr/>
+        </p:nvSpPr>
+        <p:spPr>
+          <a:xfrm>
+            <a:off x="640080" y="5897880"/>
+            <a:ext cx="10881360" cy="411480"/>
+          </a:xfrm>
+          <a:prstGeom prst="rect">
+            <a:avLst/>
+          </a:prstGeom>
+          <a:noFill/>
+          <a:ln/>
+        </p:spPr>
+        <p:txBody>
+          <a:bodyPr wrap="square" rtlCol="0" anchor="ctr"/>
+          <a:lstStyle/>
+          <a:p>
+            <a:pPr indent="0" marL="0">
+              <a:buNone/>
+            </a:pPr>
+            <a:r>
+              <a:rPr lang="en-US" sz="1600" i="1" dirty="0">
+                <a:solidFill>
+                  <a:srgbClr val="1A1A1A"/>
                 </a:solidFill>
                 <a:latin typeface="Cambria" pitchFamily="34" charset="0"/>
                 <a:ea typeface="Cambria" pitchFamily="34" charset="-122"/>
                 <a:cs typeface="Cambria" pitchFamily="34" charset="-120"/>
               </a:rPr>
-              <a:t>Read robots.txt and the terms</a:t>
-            </a:r>
-            <a:endParaRPr lang="en-US" sz="1700" dirty="0"/>
-          </a:p>
-        </p:txBody>
-      </p:sp>
-      <p:sp>
-        <p:nvSpPr>
-          <p:cNvPr id="6" name="Text 4"/>
-          <p:cNvSpPr/>
-          <p:nvPr/>
-        </p:nvSpPr>
-        <p:spPr>
-          <a:xfrm>
-            <a:off x="5120640" y="2103120"/>
-            <a:ext cx="6126480" cy="731520"/>
-          </a:xfrm>
-          <a:prstGeom prst="rect">
-            <a:avLst/>
-          </a:prstGeom>
-          <a:noFill/>
-          <a:ln/>
-        </p:spPr>
-        <p:txBody>
-          <a:bodyPr wrap="square" lIns="0" tIns="0" rIns="0" bIns="0" rtlCol="0" anchor="ctr"/>
-          <a:lstStyle/>
-          <a:p>
-            <a:pPr indent="0" marL="0">
-              <a:buNone/>
-            </a:pPr>
-            <a:r>
-              <a:rPr lang="en-US" sz="1350" dirty="0">
-                <a:solidFill>
-                  <a:srgbClr val="1A1A1A"/>
+              <a:t>An endpoint is a URL that answers with data. A key is a name badge. Pagination hands you a page at a time.</a:t>
+            </a:r>
+            <a:endParaRPr lang="en-US" sz="1600" dirty="0"/>
+          </a:p>
+        </p:txBody>
+      </p:sp>
+      <p:sp>
+        <p:nvSpPr>
+          <p:cNvPr id="6" name="Text 3"/>
+          <p:cNvSpPr/>
+          <p:nvPr/>
+        </p:nvSpPr>
+        <p:spPr>
+          <a:xfrm>
+            <a:off x="640080" y="6355080"/>
+            <a:ext cx="10881360" cy="320040"/>
+          </a:xfrm>
+          <a:prstGeom prst="rect">
+            <a:avLst/>
+          </a:prstGeom>
+          <a:noFill/>
+          <a:ln/>
+        </p:spPr>
+        <p:txBody>
+          <a:bodyPr wrap="square" rtlCol="0" anchor="ctr"/>
+          <a:lstStyle/>
+          <a:p>
+            <a:pPr indent="0" marL="0">
+              <a:buNone/>
+            </a:pPr>
+            <a:r>
+              <a:rPr lang="en-US" sz="1000" dirty="0">
+                <a:solidFill>
+                  <a:srgbClr val="6B6B63"/>
                 </a:solidFill>
                 <a:latin typeface="Calibri" pitchFamily="34" charset="0"/>
                 <a:ea typeface="Calibri" pitchFamily="34" charset="-122"/>
                 <a:cs typeface="Calibri" pitchFamily="34" charset="-120"/>
               </a:rPr>
-              <a:t>before the first request, not after the complaint.</a:t>
-            </a:r>
-            <a:endParaRPr lang="en-US" sz="1350" dirty="0"/>
-          </a:p>
-        </p:txBody>
-      </p:sp>
-      <p:sp>
-        <p:nvSpPr>
-          <p:cNvPr id="7" name="Shape 5"/>
-          <p:cNvSpPr/>
-          <p:nvPr/>
-        </p:nvSpPr>
-        <p:spPr>
-          <a:xfrm>
-            <a:off x="640080" y="3063240"/>
-            <a:ext cx="10881360" cy="914400"/>
-          </a:xfrm>
-          <a:prstGeom prst="roundRect">
-            <a:avLst>
-              <a:gd name="adj" fmla="val 10000"/>
-            </a:avLst>
-          </a:prstGeom>
-          <a:solidFill>
-            <a:srgbClr val="F4EEE8"/>
-          </a:solidFill>
-          <a:ln/>
-        </p:spPr>
-      </p:sp>
-      <p:sp>
-        <p:nvSpPr>
-          <p:cNvPr id="8" name="Text 6"/>
-          <p:cNvSpPr/>
-          <p:nvPr/>
-        </p:nvSpPr>
-        <p:spPr>
-          <a:xfrm>
-            <a:off x="960120" y="3154680"/>
-            <a:ext cx="4023360" cy="731520"/>
-          </a:xfrm>
-          <a:prstGeom prst="rect">
-            <a:avLst/>
-          </a:prstGeom>
-          <a:noFill/>
-          <a:ln/>
-        </p:spPr>
-        <p:txBody>
-          <a:bodyPr wrap="square" lIns="0" tIns="0" rIns="0" bIns="0" rtlCol="0" anchor="ctr"/>
-          <a:lstStyle/>
-          <a:p>
-            <a:pPr indent="0" marL="0">
-              <a:buNone/>
-            </a:pPr>
-            <a:r>
-              <a:rPr lang="en-US" sz="1700" b="1" dirty="0">
-                <a:solidFill>
-                  <a:srgbClr val="B9852F"/>
-                </a:solidFill>
-                <a:latin typeface="Cambria" pitchFamily="34" charset="0"/>
-                <a:ea typeface="Cambria" pitchFamily="34" charset="-122"/>
-                <a:cs typeface="Cambria" pitchFamily="34" charset="-120"/>
-              </a:rPr>
-              <a:t>Request slowly</a:t>
-            </a:r>
-            <a:endParaRPr lang="en-US" sz="1700" dirty="0"/>
-          </a:p>
-        </p:txBody>
-      </p:sp>
-      <p:sp>
-        <p:nvSpPr>
-          <p:cNvPr id="9" name="Text 7"/>
-          <p:cNvSpPr/>
-          <p:nvPr/>
-        </p:nvSpPr>
-        <p:spPr>
-          <a:xfrm>
-            <a:off x="5120640" y="3154680"/>
-            <a:ext cx="6126480" cy="731520"/>
-          </a:xfrm>
-          <a:prstGeom prst="rect">
-            <a:avLst/>
-          </a:prstGeom>
-          <a:noFill/>
-          <a:ln/>
-        </p:spPr>
-        <p:txBody>
-          <a:bodyPr wrap="square" lIns="0" tIns="0" rIns="0" bIns="0" rtlCol="0" anchor="ctr"/>
-          <a:lstStyle/>
-          <a:p>
-            <a:pPr indent="0" marL="0">
-              <a:buNone/>
-            </a:pPr>
-            <a:r>
-              <a:rPr lang="en-US" sz="1350" dirty="0">
-                <a:solidFill>
-                  <a:srgbClr val="1A1A1A"/>
-                </a:solidFill>
-                <a:latin typeface="Calibri" pitchFamily="34" charset="0"/>
-                <a:ea typeface="Calibri" pitchFamily="34" charset="-122"/>
-                <a:cs typeface="Calibri" pitchFamily="34" charset="-120"/>
-              </a:rPr>
-              <a:t>one page every couple of seconds. You are a guest on someone's server.</a:t>
-            </a:r>
-            <a:endParaRPr lang="en-US" sz="1350" dirty="0"/>
-          </a:p>
-        </p:txBody>
-      </p:sp>
-      <p:sp>
-        <p:nvSpPr>
-          <p:cNvPr id="10" name="Shape 8"/>
-          <p:cNvSpPr/>
-          <p:nvPr/>
-        </p:nvSpPr>
-        <p:spPr>
-          <a:xfrm>
-            <a:off x="640080" y="4114800"/>
-            <a:ext cx="10881360" cy="914400"/>
-          </a:xfrm>
-          <a:prstGeom prst="roundRect">
-            <a:avLst>
-              <a:gd name="adj" fmla="val 10000"/>
-            </a:avLst>
-          </a:prstGeom>
-          <a:solidFill>
-            <a:srgbClr val="F4EEE8"/>
-          </a:solidFill>
-          <a:ln/>
-        </p:spPr>
-      </p:sp>
-      <p:sp>
-        <p:nvSpPr>
-          <p:cNvPr id="11" name="Text 9"/>
-          <p:cNvSpPr/>
-          <p:nvPr/>
-        </p:nvSpPr>
-        <p:spPr>
-          <a:xfrm>
-            <a:off x="960120" y="4206240"/>
-            <a:ext cx="4023360" cy="731520"/>
-          </a:xfrm>
-          <a:prstGeom prst="rect">
-            <a:avLst/>
-          </a:prstGeom>
-          <a:noFill/>
-          <a:ln/>
-        </p:spPr>
-        <p:txBody>
-          <a:bodyPr wrap="square" lIns="0" tIns="0" rIns="0" bIns="0" rtlCol="0" anchor="ctr"/>
-          <a:lstStyle/>
-          <a:p>
-            <a:pPr indent="0" marL="0">
-              <a:buNone/>
-            </a:pPr>
-            <a:r>
-              <a:rPr lang="en-US" sz="1700" b="1" dirty="0">
-                <a:solidFill>
-                  <a:srgbClr val="3F6F5F"/>
-                </a:solidFill>
-                <a:latin typeface="Cambria" pitchFamily="34" charset="0"/>
-                <a:ea typeface="Cambria" pitchFamily="34" charset="-122"/>
-                <a:cs typeface="Cambria" pitchFamily="34" charset="-120"/>
-              </a:rPr>
-              <a:t>Take only what you need</a:t>
-            </a:r>
-            <a:endParaRPr lang="en-US" sz="1700" dirty="0"/>
-          </a:p>
-        </p:txBody>
-      </p:sp>
-      <p:sp>
-        <p:nvSpPr>
-          <p:cNvPr id="12" name="Text 10"/>
-          <p:cNvSpPr/>
-          <p:nvPr/>
-        </p:nvSpPr>
-        <p:spPr>
-          <a:xfrm>
-            <a:off x="5120640" y="4206240"/>
-            <a:ext cx="6126480" cy="731520"/>
-          </a:xfrm>
-          <a:prstGeom prst="rect">
-            <a:avLst/>
-          </a:prstGeom>
-          <a:noFill/>
-          <a:ln/>
-        </p:spPr>
-        <p:txBody>
-          <a:bodyPr wrap="square" lIns="0" tIns="0" rIns="0" bIns="0" rtlCol="0" anchor="ctr"/>
-          <a:lstStyle/>
-          <a:p>
-            <a:pPr indent="0" marL="0">
-              <a:buNone/>
-            </a:pPr>
-            <a:r>
-              <a:rPr lang="en-US" sz="1350" dirty="0">
-                <a:solidFill>
-                  <a:srgbClr val="1A1A1A"/>
-                </a:solidFill>
-                <a:latin typeface="Calibri" pitchFamily="34" charset="0"/>
-                <a:ea typeface="Calibri" pitchFamily="34" charset="-122"/>
-                <a:cs typeface="Calibri" pitchFamily="34" charset="-120"/>
-              </a:rPr>
-              <a:t>the fields your question uses, not the whole site.</a:t>
-            </a:r>
-            <a:endParaRPr lang="en-US" sz="1350" dirty="0"/>
-          </a:p>
-        </p:txBody>
-      </p:sp>
-      <p:sp>
-        <p:nvSpPr>
-          <p:cNvPr id="13" name="Shape 11"/>
-          <p:cNvSpPr/>
-          <p:nvPr/>
-        </p:nvSpPr>
-        <p:spPr>
-          <a:xfrm>
-            <a:off x="640080" y="5166360"/>
-            <a:ext cx="10881360" cy="914400"/>
-          </a:xfrm>
-          <a:prstGeom prst="roundRect">
-            <a:avLst>
-              <a:gd name="adj" fmla="val 10000"/>
-            </a:avLst>
-          </a:prstGeom>
-          <a:solidFill>
-            <a:srgbClr val="F4EEE8"/>
-          </a:solidFill>
-          <a:ln/>
-        </p:spPr>
-      </p:sp>
-      <p:sp>
-        <p:nvSpPr>
-          <p:cNvPr id="14" name="Text 12"/>
-          <p:cNvSpPr/>
-          <p:nvPr/>
-        </p:nvSpPr>
-        <p:spPr>
-          <a:xfrm>
-            <a:off x="960120" y="5257800"/>
-            <a:ext cx="4023360" cy="731520"/>
-          </a:xfrm>
-          <a:prstGeom prst="rect">
-            <a:avLst/>
-          </a:prstGeom>
-          <a:noFill/>
-          <a:ln/>
-        </p:spPr>
-        <p:txBody>
-          <a:bodyPr wrap="square" lIns="0" tIns="0" rIns="0" bIns="0" rtlCol="0" anchor="ctr"/>
-          <a:lstStyle/>
-          <a:p>
-            <a:pPr indent="0" marL="0">
-              <a:buNone/>
-            </a:pPr>
-            <a:r>
-              <a:rPr lang="en-US" sz="1700" b="1" dirty="0">
-                <a:solidFill>
-                  <a:srgbClr val="2E5F8A"/>
-                </a:solidFill>
-                <a:latin typeface="Cambria" pitchFamily="34" charset="0"/>
-                <a:ea typeface="Cambria" pitchFamily="34" charset="-122"/>
-                <a:cs typeface="Cambria" pitchFamily="34" charset="-120"/>
-              </a:rPr>
-              <a:t>Never republish the text</a:t>
-            </a:r>
-            <a:endParaRPr lang="en-US" sz="1700" dirty="0"/>
-          </a:p>
-        </p:txBody>
-      </p:sp>
-      <p:sp>
-        <p:nvSpPr>
-          <p:cNvPr id="15" name="Text 13"/>
-          <p:cNvSpPr/>
-          <p:nvPr/>
-        </p:nvSpPr>
-        <p:spPr>
-          <a:xfrm>
-            <a:off x="5120640" y="5257800"/>
-            <a:ext cx="6126480" cy="731520"/>
-          </a:xfrm>
-          <a:prstGeom prst="rect">
-            <a:avLst/>
-          </a:prstGeom>
-          <a:noFill/>
-          <a:ln/>
-        </p:spPr>
-        <p:txBody>
-          <a:bodyPr wrap="square" lIns="0" tIns="0" rIns="0" bIns="0" rtlCol="0" anchor="ctr"/>
-          <a:lstStyle/>
-          <a:p>
-            <a:pPr indent="0" marL="0">
-              <a:buNone/>
-            </a:pPr>
-            <a:r>
-              <a:rPr lang="en-US" sz="1350" dirty="0">
-                <a:solidFill>
-                  <a:srgbClr val="1A1A1A"/>
-                </a:solidFill>
-                <a:latin typeface="Calibri" pitchFamily="34" charset="0"/>
-                <a:ea typeface="Calibri" pitchFamily="34" charset="-122"/>
-                <a:cs typeface="Calibri" pitchFamily="34" charset="-120"/>
-              </a:rPr>
-              <a:t>analyse it, quote it, count it. Do not hand it on.</a:t>
-            </a:r>
-            <a:endParaRPr lang="en-US" sz="1350" dirty="0"/>
-          </a:p>
-        </p:txBody>
-      </p:sp>
-      <p:sp>
-        <p:nvSpPr>
-          <p:cNvPr id="16" name="Text 14"/>
-          <p:cNvSpPr/>
-          <p:nvPr/>
-        </p:nvSpPr>
-        <p:spPr>
-          <a:xfrm>
-            <a:off x="640080" y="6309360"/>
-            <a:ext cx="10881360" cy="365760"/>
-          </a:xfrm>
-          <a:prstGeom prst="rect">
-            <a:avLst/>
-          </a:prstGeom>
-          <a:noFill/>
-          <a:ln/>
-        </p:spPr>
-        <p:txBody>
-          <a:bodyPr wrap="square" rtlCol="0" anchor="ctr"/>
-          <a:lstStyle/>
-          <a:p>
-            <a:pPr indent="0" marL="0">
-              <a:buNone/>
-            </a:pPr>
-            <a:r>
-              <a:rPr lang="en-US" sz="1250" i="1" dirty="0">
-                <a:solidFill>
-                  <a:srgbClr val="6B6B63"/>
-                </a:solidFill>
-                <a:latin typeface="Calibri" pitchFamily="34" charset="0"/>
-                <a:ea typeface="Calibri" pitchFamily="34" charset="-122"/>
-                <a:cs typeface="Calibri" pitchFamily="34" charset="-120"/>
-              </a:rPr>
-              <a:t>CC0 and public domain: go anywhere.   Academic sets and community text: analyse, don't redistribute.   Shadow libraries: never.</a:t>
-            </a:r>
-            <a:endParaRPr lang="en-US" sz="1250" dirty="0"/>
+              <a:t>Left panel: a real response, live from api.artic.edu. The AI writes the three lines that make the table.</a:t>
+            </a:r>
+            <a:endParaRPr lang="en-US" sz="1000" dirty="0"/>
           </a:p>
         </p:txBody>
       </p:sp>
@@ -9111,13 +9129,13 @@
             <a:r>
               <a:rPr lang="en-US" sz="1300" b="1" spc="300" kern="0" dirty="0">
                 <a:solidFill>
-                  <a:srgbClr val="3F6F5F"/>
+                  <a:srgbClr val="B9852F"/>
                 </a:solidFill>
                 <a:latin typeface="Calibri" pitchFamily="34" charset="0"/>
                 <a:ea typeface="Calibri" pitchFamily="34" charset="-122"/>
                 <a:cs typeface="Calibri" pitchFamily="34" charset="-120"/>
               </a:rPr>
-              <a:t>YOUR TURN · 20 MINUTES</a:t>
+              <a:t>EVERY API IS SOMEBODY'S DESIGN</a:t>
             </a:r>
             <a:endParaRPr lang="en-US" sz="1300" dirty="0"/>
           </a:p>
@@ -9156,348 +9174,110 @@
                 <a:ea typeface="Cambria" pitchFamily="34" charset="-122"/>
                 <a:cs typeface="Cambria" pitchFamily="34" charset="-120"/>
               </a:rPr>
-              <a:t>Collect it, save it, start the repo</a:t>
+              <a:t>Two museums, two shapes</a:t>
             </a:r>
             <a:endParaRPr lang="en-US" sz="3400" dirty="0"/>
           </a:p>
         </p:txBody>
       </p:sp>
-      <p:sp>
-        <p:nvSpPr>
-          <p:cNvPr id="4" name="Shape 2"/>
-          <p:cNvSpPr/>
-          <p:nvPr/>
-        </p:nvSpPr>
-        <p:spPr>
-          <a:xfrm>
-            <a:off x="640080" y="2103120"/>
-            <a:ext cx="10881360" cy="1097280"/>
-          </a:xfrm>
-          <a:prstGeom prst="roundRect">
-            <a:avLst>
-              <a:gd name="adj" fmla="val 8333"/>
-            </a:avLst>
-          </a:prstGeom>
-          <a:solidFill>
-            <a:srgbClr val="F4EEE8"/>
-          </a:solidFill>
-          <a:ln/>
-        </p:spPr>
-      </p:sp>
-      <p:sp>
-        <p:nvSpPr>
-          <p:cNvPr id="5" name="Text 3"/>
-          <p:cNvSpPr/>
-          <p:nvPr/>
-        </p:nvSpPr>
-        <p:spPr>
-          <a:xfrm>
-            <a:off x="1005840" y="2240280"/>
-            <a:ext cx="4206240" cy="822960"/>
-          </a:xfrm>
-          <a:prstGeom prst="rect">
-            <a:avLst/>
-          </a:prstGeom>
-          <a:noFill/>
-          <a:ln/>
-        </p:spPr>
-        <p:txBody>
-          <a:bodyPr wrap="square" lIns="0" tIns="0" rIns="0" bIns="0" rtlCol="0" anchor="ctr"/>
-          <a:lstStyle/>
-          <a:p>
-            <a:pPr indent="0" marL="0">
-              <a:buNone/>
-            </a:pPr>
-            <a:r>
-              <a:rPr lang="en-US" sz="1900" b="1" dirty="0">
-                <a:solidFill>
-                  <a:srgbClr val="3F6F5F"/>
+      <p:pic>
+        <p:nvPicPr>
+          <p:cNvPr id="4" name="Image 0" descr="/tmp/figs/w4_api_shapes.png">    </p:cNvPr>
+          <p:cNvPicPr>
+            <a:picLocks noChangeAspect="1"/>
+          </p:cNvPicPr>
+          <p:nvPr/>
+        </p:nvPicPr>
+        <p:blipFill>
+          <a:blip r:embed="rId1"/>
+          <a:srcRect l="0" r="0" t="0" b="0"/>
+          <a:stretch/>
+        </p:blipFill>
+        <p:spPr>
+          <a:xfrm>
+            <a:off x="1005840" y="1828800"/>
+            <a:ext cx="10149840" cy="3840480"/>
+          </a:xfrm>
+          <a:prstGeom prst="rect">
+            <a:avLst/>
+          </a:prstGeom>
+        </p:spPr>
+      </p:pic>
+      <p:sp>
+        <p:nvSpPr>
+          <p:cNvPr id="5" name="Text 2"/>
+          <p:cNvSpPr/>
+          <p:nvPr/>
+        </p:nvSpPr>
+        <p:spPr>
+          <a:xfrm>
+            <a:off x="640080" y="5897880"/>
+            <a:ext cx="10881360" cy="411480"/>
+          </a:xfrm>
+          <a:prstGeom prst="rect">
+            <a:avLst/>
+          </a:prstGeom>
+          <a:noFill/>
+          <a:ln/>
+        </p:spPr>
+        <p:txBody>
+          <a:bodyPr wrap="square" rtlCol="0" anchor="ctr"/>
+          <a:lstStyle/>
+          <a:p>
+            <a:pPr indent="0" marL="0">
+              <a:buNone/>
+            </a:pPr>
+            <a:r>
+              <a:rPr lang="en-US" sz="1600" i="1" dirty="0">
+                <a:solidFill>
+                  <a:srgbClr val="1A1A1A"/>
                 </a:solidFill>
                 <a:latin typeface="Cambria" pitchFamily="34" charset="0"/>
                 <a:ea typeface="Cambria" pitchFamily="34" charset="-122"/>
                 <a:cs typeface="Cambria" pitchFamily="34" charset="-120"/>
               </a:rPr>
-              <a:t>a file in your Drive folder</a:t>
-            </a:r>
-            <a:endParaRPr lang="en-US" sz="1900" dirty="0"/>
-          </a:p>
-        </p:txBody>
-      </p:sp>
-      <p:sp>
-        <p:nvSpPr>
-          <p:cNvPr id="6" name="Text 4"/>
-          <p:cNvSpPr/>
-          <p:nvPr/>
-        </p:nvSpPr>
-        <p:spPr>
-          <a:xfrm>
-            <a:off x="5394960" y="2240280"/>
-            <a:ext cx="5760720" cy="822960"/>
-          </a:xfrm>
-          <a:prstGeom prst="rect">
-            <a:avLst/>
-          </a:prstGeom>
-          <a:noFill/>
-          <a:ln/>
-        </p:spPr>
-        <p:txBody>
-          <a:bodyPr wrap="square" lIns="0" tIns="0" rIns="0" bIns="0" rtlCol="0" anchor="ctr"/>
-          <a:lstStyle/>
-          <a:p>
-            <a:pPr indent="0" marL="0">
-              <a:buNone/>
-            </a:pPr>
-            <a:r>
-              <a:rPr lang="en-US" sz="1400" dirty="0">
-                <a:solidFill>
-                  <a:srgbClr val="1A1A1A"/>
+              <a:t>One hands you rows. The other hands you a phone book, and every row after that is another request.</a:t>
+            </a:r>
+            <a:endParaRPr lang="en-US" sz="1600" dirty="0"/>
+          </a:p>
+        </p:txBody>
+      </p:sp>
+      <p:sp>
+        <p:nvSpPr>
+          <p:cNvPr id="6" name="Text 3"/>
+          <p:cNvSpPr/>
+          <p:nvPr/>
+        </p:nvSpPr>
+        <p:spPr>
+          <a:xfrm>
+            <a:off x="640080" y="6355080"/>
+            <a:ext cx="10881360" cy="320040"/>
+          </a:xfrm>
+          <a:prstGeom prst="rect">
+            <a:avLst/>
+          </a:prstGeom>
+          <a:noFill/>
+          <a:ln/>
+        </p:spPr>
+        <p:txBody>
+          <a:bodyPr wrap="square" rtlCol="0" anchor="ctr"/>
+          <a:lstStyle/>
+          <a:p>
+            <a:pPr indent="0" marL="0">
+              <a:buNone/>
+            </a:pPr>
+            <a:r>
+              <a:rPr lang="en-US" sz="1000" dirty="0">
+                <a:solidFill>
+                  <a:srgbClr val="6B6B63"/>
                 </a:solidFill>
                 <a:latin typeface="Calibri" pitchFamily="34" charset="0"/>
                 <a:ea typeface="Calibri" pitchFamily="34" charset="-122"/>
                 <a:cs typeface="Calibri" pitchFamily="34" charset="-120"/>
               </a:rPr>
-              <a:t>Week 5 starts from it. Colab forgets everything else.</a:t>
-            </a:r>
-            <a:endParaRPr lang="en-US" sz="1400" dirty="0"/>
-          </a:p>
-        </p:txBody>
-      </p:sp>
-      <p:sp>
-        <p:nvSpPr>
-          <p:cNvPr id="7" name="Shape 5"/>
-          <p:cNvSpPr/>
-          <p:nvPr/>
-        </p:nvSpPr>
-        <p:spPr>
-          <a:xfrm>
-            <a:off x="640080" y="3383280"/>
-            <a:ext cx="10881360" cy="1097280"/>
-          </a:xfrm>
-          <a:prstGeom prst="roundRect">
-            <a:avLst>
-              <a:gd name="adj" fmla="val 8333"/>
-            </a:avLst>
-          </a:prstGeom>
-          <a:solidFill>
-            <a:srgbClr val="F4EEE8"/>
-          </a:solidFill>
-          <a:ln/>
-        </p:spPr>
-      </p:sp>
-      <p:sp>
-        <p:nvSpPr>
-          <p:cNvPr id="8" name="Text 6"/>
-          <p:cNvSpPr/>
-          <p:nvPr/>
-        </p:nvSpPr>
-        <p:spPr>
-          <a:xfrm>
-            <a:off x="1005840" y="3520440"/>
-            <a:ext cx="4206240" cy="822960"/>
-          </a:xfrm>
-          <a:prstGeom prst="rect">
-            <a:avLst/>
-          </a:prstGeom>
-          <a:noFill/>
-          <a:ln/>
-        </p:spPr>
-        <p:txBody>
-          <a:bodyPr wrap="square" lIns="0" tIns="0" rIns="0" bIns="0" rtlCol="0" anchor="ctr"/>
-          <a:lstStyle/>
-          <a:p>
-            <a:pPr indent="0" marL="0">
-              <a:buNone/>
-            </a:pPr>
-            <a:r>
-              <a:rPr lang="en-US" sz="1900" b="1" dirty="0">
-                <a:solidFill>
-                  <a:srgbClr val="2E5F8A"/>
-                </a:solidFill>
-                <a:latin typeface="Cambria" pitchFamily="34" charset="0"/>
-                <a:ea typeface="Cambria" pitchFamily="34" charset="-122"/>
-                <a:cs typeface="Cambria" pitchFamily="34" charset="-120"/>
-              </a:rPr>
-              <a:t>a repo with Pages switched on</a:t>
-            </a:r>
-            <a:endParaRPr lang="en-US" sz="1900" dirty="0"/>
-          </a:p>
-        </p:txBody>
-      </p:sp>
-      <p:sp>
-        <p:nvSpPr>
-          <p:cNvPr id="9" name="Text 7"/>
-          <p:cNvSpPr/>
-          <p:nvPr/>
-        </p:nvSpPr>
-        <p:spPr>
-          <a:xfrm>
-            <a:off x="5394960" y="3520440"/>
-            <a:ext cx="5760720" cy="822960"/>
-          </a:xfrm>
-          <a:prstGeom prst="rect">
-            <a:avLst/>
-          </a:prstGeom>
-          <a:noFill/>
-          <a:ln/>
-        </p:spPr>
-        <p:txBody>
-          <a:bodyPr wrap="square" lIns="0" tIns="0" rIns="0" bIns="0" rtlCol="0" anchor="ctr"/>
-          <a:lstStyle/>
-          <a:p>
-            <a:pPr indent="0" marL="0">
-              <a:buNone/>
-            </a:pPr>
-            <a:r>
-              <a:rPr lang="en-US" sz="1400" dirty="0">
-                <a:solidFill>
-                  <a:srgbClr val="1A1A1A"/>
-                </a:solidFill>
-                <a:latin typeface="Calibri" pitchFamily="34" charset="0"/>
-                <a:ea typeface="Calibri" pitchFamily="34" charset="-122"/>
-                <a:cs typeface="Calibri" pitchFamily="34" charset="-120"/>
-              </a:rPr>
-              <a:t>so a live URL exists today, not in Week 9 under deadline.</a:t>
-            </a:r>
-            <a:endParaRPr lang="en-US" sz="1400" dirty="0"/>
-          </a:p>
-        </p:txBody>
-      </p:sp>
-      <p:sp>
-        <p:nvSpPr>
-          <p:cNvPr id="10" name="Shape 8"/>
-          <p:cNvSpPr/>
-          <p:nvPr/>
-        </p:nvSpPr>
-        <p:spPr>
-          <a:xfrm>
-            <a:off x="640080" y="4663440"/>
-            <a:ext cx="10881360" cy="1097280"/>
-          </a:xfrm>
-          <a:prstGeom prst="roundRect">
-            <a:avLst>
-              <a:gd name="adj" fmla="val 8333"/>
-            </a:avLst>
-          </a:prstGeom>
-          <a:solidFill>
-            <a:srgbClr val="F4EEE8"/>
-          </a:solidFill>
-          <a:ln/>
-        </p:spPr>
-      </p:sp>
-      <p:sp>
-        <p:nvSpPr>
-          <p:cNvPr id="11" name="Text 9"/>
-          <p:cNvSpPr/>
-          <p:nvPr/>
-        </p:nvSpPr>
-        <p:spPr>
-          <a:xfrm>
-            <a:off x="1005840" y="4800600"/>
-            <a:ext cx="4206240" cy="822960"/>
-          </a:xfrm>
-          <a:prstGeom prst="rect">
-            <a:avLst/>
-          </a:prstGeom>
-          <a:noFill/>
-          <a:ln/>
-        </p:spPr>
-        <p:txBody>
-          <a:bodyPr wrap="square" lIns="0" tIns="0" rIns="0" bIns="0" rtlCol="0" anchor="ctr"/>
-          <a:lstStyle/>
-          <a:p>
-            <a:pPr indent="0" marL="0">
-              <a:buNone/>
-            </a:pPr>
-            <a:r>
-              <a:rPr lang="en-US" sz="1900" b="1" dirty="0">
-                <a:solidFill>
-                  <a:srgbClr val="7A3B2E"/>
-                </a:solidFill>
-                <a:latin typeface="Cambria" pitchFamily="34" charset="0"/>
-                <a:ea typeface="Cambria" pitchFamily="34" charset="-122"/>
-                <a:cs typeface="Cambria" pitchFamily="34" charset="-120"/>
-              </a:rPr>
-              <a:t>two minutes of pitch, to a partner</a:t>
-            </a:r>
-            <a:endParaRPr lang="en-US" sz="1900" dirty="0"/>
-          </a:p>
-        </p:txBody>
-      </p:sp>
-      <p:sp>
-        <p:nvSpPr>
-          <p:cNvPr id="12" name="Text 10"/>
-          <p:cNvSpPr/>
-          <p:nvPr/>
-        </p:nvSpPr>
-        <p:spPr>
-          <a:xfrm>
-            <a:off x="5394960" y="4800600"/>
-            <a:ext cx="5760720" cy="822960"/>
-          </a:xfrm>
-          <a:prstGeom prst="rect">
-            <a:avLst/>
-          </a:prstGeom>
-          <a:noFill/>
-          <a:ln/>
-        </p:spPr>
-        <p:txBody>
-          <a:bodyPr wrap="square" lIns="0" tIns="0" rIns="0" bIns="0" rtlCol="0" anchor="ctr"/>
-          <a:lstStyle/>
-          <a:p>
-            <a:pPr indent="0" marL="0">
-              <a:buNone/>
-            </a:pPr>
-            <a:r>
-              <a:rPr lang="en-US" sz="1400" dirty="0">
-                <a:solidFill>
-                  <a:srgbClr val="1A1A1A"/>
-                </a:solidFill>
-                <a:latin typeface="Calibri" pitchFamily="34" charset="0"/>
-                <a:ea typeface="Calibri" pitchFamily="34" charset="-122"/>
-                <a:cs typeface="Calibri" pitchFamily="34" charset="-120"/>
-              </a:rPr>
-              <a:t>corpus, two methods, what would count as a finding.</a:t>
-            </a:r>
-            <a:endParaRPr lang="en-US" sz="1400" dirty="0"/>
-          </a:p>
-        </p:txBody>
-      </p:sp>
-      <p:sp>
-        <p:nvSpPr>
-          <p:cNvPr id="13" name="Text 11"/>
-          <p:cNvSpPr/>
-          <p:nvPr/>
-        </p:nvSpPr>
-        <p:spPr>
-          <a:xfrm>
-            <a:off x="640080" y="6263640"/>
-            <a:ext cx="10881360" cy="365760"/>
-          </a:xfrm>
-          <a:prstGeom prst="rect">
-            <a:avLst/>
-          </a:prstGeom>
-          <a:noFill/>
-          <a:ln/>
-        </p:spPr>
-        <p:txBody>
-          <a:bodyPr wrap="square" rtlCol="0" anchor="ctr"/>
-          <a:lstStyle/>
-          <a:p>
-            <a:pPr indent="0" marL="0">
-              <a:buNone/>
-            </a:pPr>
-            <a:r>
-              <a:rPr lang="en-US" sz="1100" i="1" dirty="0">
-                <a:solidFill>
-                  <a:srgbClr val="6B6B63"/>
-                </a:solidFill>
-                <a:latin typeface="Calibri" pitchFamily="34" charset="0"/>
-                <a:ea typeface="Calibri" pitchFamily="34" charset="-122"/>
-                <a:cs typeface="Calibri" pitchFamily="34" charset="-120"/>
-              </a:rPr>
-              <a:t>A null result, honestly shown, is a complete project. The pivot kit is insurance, not a demotion.</a:t>
-            </a:r>
-            <a:endParaRPr lang="en-US" sz="1100" dirty="0"/>
+              <a:t>Both queried live for this slide. Work out which kind you have before you estimate how long anything will take.</a:t>
+            </a:r>
+            <a:endParaRPr lang="en-US" sz="1000" dirty="0"/>
           </a:p>
         </p:txBody>
       </p:sp>
@@ -9515,7 +9295,7 @@
     <p:bg>
       <p:bgPr>
         <a:solidFill>
-          <a:srgbClr val="4E261D"/>
+          <a:srgbClr val="FFFFFF"/>
         </a:solidFill>
       </p:bgPr>
     </p:bg>
@@ -9560,13 +9340,13 @@
             <a:r>
               <a:rPr lang="en-US" sz="1300" b="1" spc="300" kern="0" dirty="0">
                 <a:solidFill>
-                  <a:srgbClr val="B9852F"/>
+                  <a:srgbClr val="7A3B2E"/>
                 </a:solidFill>
                 <a:latin typeface="Calibri" pitchFamily="34" charset="0"/>
                 <a:ea typeface="Calibri" pitchFamily="34" charset="-122"/>
                 <a:cs typeface="Calibri" pitchFamily="34" charset="-120"/>
               </a:rPr>
-              <a:t>BEFORE WEEK 5</a:t>
+              <a:t>ROUTE THREE</a:t>
             </a:r>
             <a:endParaRPr lang="en-US" sz="1300" dirty="0"/>
           </a:p>
@@ -9580,17 +9360,17 @@
         </p:nvSpPr>
         <p:spPr>
           <a:xfrm>
-            <a:off x="640080" y="914400"/>
-            <a:ext cx="10058400" cy="731520"/>
-          </a:xfrm>
-          <a:prstGeom prst="rect">
-            <a:avLst/>
-          </a:prstGeom>
-          <a:noFill/>
-          <a:ln/>
-        </p:spPr>
-        <p:txBody>
-          <a:bodyPr wrap="square" rtlCol="0" anchor="ctr"/>
+            <a:off x="640080" y="868680"/>
+            <a:ext cx="10972800" cy="777240"/>
+          </a:xfrm>
+          <a:prstGeom prst="rect">
+            <a:avLst/>
+          </a:prstGeom>
+          <a:noFill/>
+          <a:ln/>
+        </p:spPr>
+        <p:txBody>
+          <a:bodyPr wrap="square" rtlCol="0" anchor="t"/>
           <a:lstStyle/>
           <a:p>
             <a:pPr indent="0" marL="0">
@@ -9599,13 +9379,13 @@
             <a:r>
               <a:rPr lang="en-US" sz="3400" b="1" dirty="0">
                 <a:solidFill>
-                  <a:srgbClr val="FFFFFF"/>
+                  <a:srgbClr val="1A1A1A"/>
                 </a:solidFill>
                 <a:latin typeface="Cambria" pitchFamily="34" charset="0"/>
                 <a:ea typeface="Cambria" pitchFamily="34" charset="-122"/>
                 <a:cs typeface="Cambria" pitchFamily="34" charset="-120"/>
               </a:rPr>
-              <a:t>Homework</a:t>
+              <a:t>Scraping, and the four things that come with it</a:t>
             </a:r>
             <a:endParaRPr lang="en-US" sz="3400" dirty="0"/>
           </a:p>
@@ -9619,14 +9399,16 @@
         </p:nvSpPr>
         <p:spPr>
           <a:xfrm>
-            <a:off x="640080" y="2057400"/>
-            <a:ext cx="219456" cy="219456"/>
-          </a:xfrm>
-          <a:prstGeom prst="ellipse">
-            <a:avLst/>
+            <a:off x="640080" y="2011680"/>
+            <a:ext cx="10881360" cy="914400"/>
+          </a:xfrm>
+          <a:prstGeom prst="roundRect">
+            <a:avLst>
+              <a:gd name="adj" fmla="val 10000"/>
+            </a:avLst>
           </a:prstGeom>
           <a:solidFill>
-            <a:srgbClr val="B9852F"/>
+            <a:srgbClr val="F4EEE8"/>
           </a:solidFill>
           <a:ln/>
         </p:spPr>
@@ -9639,8 +9421,8 @@
         </p:nvSpPr>
         <p:spPr>
           <a:xfrm>
-            <a:off x="1051560" y="1920240"/>
-            <a:ext cx="10058400" cy="365760"/>
+            <a:off x="960120" y="2103120"/>
+            <a:ext cx="4023360" cy="731520"/>
           </a:xfrm>
           <a:prstGeom prst="rect">
             <a:avLst/>
@@ -9656,89 +9438,191 @@
               <a:buNone/>
             </a:pPr>
             <a:r>
-              <a:rPr lang="en-US" sz="1500" b="1" dirty="0">
-                <a:solidFill>
-                  <a:srgbClr val="B9852F"/>
+              <a:rPr lang="en-US" sz="1700" b="1" dirty="0">
+                <a:solidFill>
+                  <a:srgbClr val="7A3B2E"/>
+                </a:solidFill>
+                <a:latin typeface="Cambria" pitchFamily="34" charset="0"/>
+                <a:ea typeface="Cambria" pitchFamily="34" charset="-122"/>
+                <a:cs typeface="Cambria" pitchFamily="34" charset="-120"/>
+              </a:rPr>
+              <a:t>Read robots.txt and the terms</a:t>
+            </a:r>
+            <a:endParaRPr lang="en-US" sz="1700" dirty="0"/>
+          </a:p>
+        </p:txBody>
+      </p:sp>
+      <p:sp>
+        <p:nvSpPr>
+          <p:cNvPr id="6" name="Text 4"/>
+          <p:cNvSpPr/>
+          <p:nvPr/>
+        </p:nvSpPr>
+        <p:spPr>
+          <a:xfrm>
+            <a:off x="5120640" y="2103120"/>
+            <a:ext cx="6126480" cy="731520"/>
+          </a:xfrm>
+          <a:prstGeom prst="rect">
+            <a:avLst/>
+          </a:prstGeom>
+          <a:noFill/>
+          <a:ln/>
+        </p:spPr>
+        <p:txBody>
+          <a:bodyPr wrap="square" lIns="0" tIns="0" rIns="0" bIns="0" rtlCol="0" anchor="ctr"/>
+          <a:lstStyle/>
+          <a:p>
+            <a:pPr indent="0" marL="0">
+              <a:buNone/>
+            </a:pPr>
+            <a:r>
+              <a:rPr lang="en-US" sz="1350" dirty="0">
+                <a:solidFill>
+                  <a:srgbClr val="1A1A1A"/>
                 </a:solidFill>
                 <a:latin typeface="Calibri" pitchFamily="34" charset="0"/>
                 <a:ea typeface="Calibri" pitchFamily="34" charset="-122"/>
                 <a:cs typeface="Calibri" pitchFamily="34" charset="-120"/>
               </a:rPr>
-              <a:t>Data Biography</a:t>
-            </a:r>
-            <a:endParaRPr lang="en-US" sz="1500" dirty="0"/>
-          </a:p>
-        </p:txBody>
-      </p:sp>
-      <p:sp>
-        <p:nvSpPr>
-          <p:cNvPr id="6" name="Text 4"/>
-          <p:cNvSpPr/>
-          <p:nvPr/>
-        </p:nvSpPr>
-        <p:spPr>
-          <a:xfrm>
-            <a:off x="1051560" y="2286000"/>
-            <a:ext cx="9875520" cy="868680"/>
-          </a:xfrm>
-          <a:prstGeom prst="rect">
-            <a:avLst/>
-          </a:prstGeom>
-          <a:noFill/>
-          <a:ln/>
-        </p:spPr>
-        <p:txBody>
-          <a:bodyPr wrap="square" lIns="0" tIns="0" rIns="0" bIns="0" rtlCol="0" anchor="t"/>
-          <a:lstStyle/>
-          <a:p>
-            <a:pPr indent="0" marL="0">
-              <a:buNone/>
-            </a:pPr>
-            <a:r>
-              <a:rPr lang="en-US" sz="1400" dirty="0">
-                <a:solidFill>
-                  <a:srgbClr val="E8DCD6"/>
+              <a:t>before the first request, not after the complaint.</a:t>
+            </a:r>
+            <a:endParaRPr lang="en-US" sz="1350" dirty="0"/>
+          </a:p>
+        </p:txBody>
+      </p:sp>
+      <p:sp>
+        <p:nvSpPr>
+          <p:cNvPr id="7" name="Shape 5"/>
+          <p:cNvSpPr/>
+          <p:nvPr/>
+        </p:nvSpPr>
+        <p:spPr>
+          <a:xfrm>
+            <a:off x="640080" y="3063240"/>
+            <a:ext cx="10881360" cy="914400"/>
+          </a:xfrm>
+          <a:prstGeom prst="roundRect">
+            <a:avLst>
+              <a:gd name="adj" fmla="val 10000"/>
+            </a:avLst>
+          </a:prstGeom>
+          <a:solidFill>
+            <a:srgbClr val="F4EEE8"/>
+          </a:solidFill>
+          <a:ln/>
+        </p:spPr>
+      </p:sp>
+      <p:sp>
+        <p:nvSpPr>
+          <p:cNvPr id="8" name="Text 6"/>
+          <p:cNvSpPr/>
+          <p:nvPr/>
+        </p:nvSpPr>
+        <p:spPr>
+          <a:xfrm>
+            <a:off x="960120" y="3154680"/>
+            <a:ext cx="4023360" cy="731520"/>
+          </a:xfrm>
+          <a:prstGeom prst="rect">
+            <a:avLst/>
+          </a:prstGeom>
+          <a:noFill/>
+          <a:ln/>
+        </p:spPr>
+        <p:txBody>
+          <a:bodyPr wrap="square" lIns="0" tIns="0" rIns="0" bIns="0" rtlCol="0" anchor="ctr"/>
+          <a:lstStyle/>
+          <a:p>
+            <a:pPr indent="0" marL="0">
+              <a:buNone/>
+            </a:pPr>
+            <a:r>
+              <a:rPr lang="en-US" sz="1700" b="1" dirty="0">
+                <a:solidFill>
+                  <a:srgbClr val="B9852F"/>
+                </a:solidFill>
+                <a:latin typeface="Cambria" pitchFamily="34" charset="0"/>
+                <a:ea typeface="Cambria" pitchFamily="34" charset="-122"/>
+                <a:cs typeface="Cambria" pitchFamily="34" charset="-120"/>
+              </a:rPr>
+              <a:t>Request slowly</a:t>
+            </a:r>
+            <a:endParaRPr lang="en-US" sz="1700" dirty="0"/>
+          </a:p>
+        </p:txBody>
+      </p:sp>
+      <p:sp>
+        <p:nvSpPr>
+          <p:cNvPr id="9" name="Text 7"/>
+          <p:cNvSpPr/>
+          <p:nvPr/>
+        </p:nvSpPr>
+        <p:spPr>
+          <a:xfrm>
+            <a:off x="5120640" y="3154680"/>
+            <a:ext cx="6126480" cy="731520"/>
+          </a:xfrm>
+          <a:prstGeom prst="rect">
+            <a:avLst/>
+          </a:prstGeom>
+          <a:noFill/>
+          <a:ln/>
+        </p:spPr>
+        <p:txBody>
+          <a:bodyPr wrap="square" lIns="0" tIns="0" rIns="0" bIns="0" rtlCol="0" anchor="ctr"/>
+          <a:lstStyle/>
+          <a:p>
+            <a:pPr indent="0" marL="0">
+              <a:buNone/>
+            </a:pPr>
+            <a:r>
+              <a:rPr lang="en-US" sz="1350" dirty="0">
+                <a:solidFill>
+                  <a:srgbClr val="1A1A1A"/>
                 </a:solidFill>
                 <a:latin typeface="Calibri" pitchFamily="34" charset="0"/>
                 <a:ea typeface="Calibri" pitchFamily="34" charset="-122"/>
                 <a:cs typeface="Calibri" pitchFamily="34" charset="-120"/>
               </a:rPr>
-              <a:t>~400 words: where it came from, who is in it, who is missing, what it cannot tell you.</a:t>
-            </a:r>
-            <a:endParaRPr lang="en-US" sz="1400" dirty="0"/>
-          </a:p>
-        </p:txBody>
-      </p:sp>
-      <p:sp>
-        <p:nvSpPr>
-          <p:cNvPr id="7" name="Shape 5"/>
-          <p:cNvSpPr/>
-          <p:nvPr/>
-        </p:nvSpPr>
-        <p:spPr>
-          <a:xfrm>
-            <a:off x="640080" y="3383280"/>
-            <a:ext cx="219456" cy="219456"/>
-          </a:xfrm>
-          <a:prstGeom prst="ellipse">
-            <a:avLst/>
+              <a:t>one page every couple of seconds. You are a guest on someone's server.</a:t>
+            </a:r>
+            <a:endParaRPr lang="en-US" sz="1350" dirty="0"/>
+          </a:p>
+        </p:txBody>
+      </p:sp>
+      <p:sp>
+        <p:nvSpPr>
+          <p:cNvPr id="10" name="Shape 8"/>
+          <p:cNvSpPr/>
+          <p:nvPr/>
+        </p:nvSpPr>
+        <p:spPr>
+          <a:xfrm>
+            <a:off x="640080" y="4114800"/>
+            <a:ext cx="10881360" cy="914400"/>
+          </a:xfrm>
+          <a:prstGeom prst="roundRect">
+            <a:avLst>
+              <a:gd name="adj" fmla="val 10000"/>
+            </a:avLst>
           </a:prstGeom>
           <a:solidFill>
-            <a:srgbClr val="3F6F5F"/>
+            <a:srgbClr val="F4EEE8"/>
           </a:solidFill>
           <a:ln/>
         </p:spPr>
       </p:sp>
       <p:sp>
         <p:nvSpPr>
-          <p:cNvPr id="8" name="Text 6"/>
-          <p:cNvSpPr/>
-          <p:nvPr/>
-        </p:nvSpPr>
-        <p:spPr>
-          <a:xfrm>
-            <a:off x="1051560" y="3246120"/>
-            <a:ext cx="10058400" cy="365760"/>
+          <p:cNvPr id="11" name="Text 9"/>
+          <p:cNvSpPr/>
+          <p:nvPr/>
+        </p:nvSpPr>
+        <p:spPr>
+          <a:xfrm>
+            <a:off x="960120" y="4206240"/>
+            <a:ext cx="4023360" cy="731520"/>
           </a:xfrm>
           <a:prstGeom prst="rect">
             <a:avLst/>
@@ -9754,167 +9638,341 @@
               <a:buNone/>
             </a:pPr>
             <a:r>
-              <a:rPr lang="en-US" sz="1500" b="1" dirty="0">
+              <a:rPr lang="en-US" sz="1700" b="1" dirty="0">
                 <a:solidFill>
                   <a:srgbClr val="3F6F5F"/>
+                </a:solidFill>
+                <a:latin typeface="Cambria" pitchFamily="34" charset="0"/>
+                <a:ea typeface="Cambria" pitchFamily="34" charset="-122"/>
+                <a:cs typeface="Cambria" pitchFamily="34" charset="-120"/>
+              </a:rPr>
+              <a:t>Take only what you need</a:t>
+            </a:r>
+            <a:endParaRPr lang="en-US" sz="1700" dirty="0"/>
+          </a:p>
+        </p:txBody>
+      </p:sp>
+      <p:sp>
+        <p:nvSpPr>
+          <p:cNvPr id="12" name="Text 10"/>
+          <p:cNvSpPr/>
+          <p:nvPr/>
+        </p:nvSpPr>
+        <p:spPr>
+          <a:xfrm>
+            <a:off x="5120640" y="4206240"/>
+            <a:ext cx="6126480" cy="731520"/>
+          </a:xfrm>
+          <a:prstGeom prst="rect">
+            <a:avLst/>
+          </a:prstGeom>
+          <a:noFill/>
+          <a:ln/>
+        </p:spPr>
+        <p:txBody>
+          <a:bodyPr wrap="square" lIns="0" tIns="0" rIns="0" bIns="0" rtlCol="0" anchor="ctr"/>
+          <a:lstStyle/>
+          <a:p>
+            <a:pPr indent="0" marL="0">
+              <a:buNone/>
+            </a:pPr>
+            <a:r>
+              <a:rPr lang="en-US" sz="1350" dirty="0">
+                <a:solidFill>
+                  <a:srgbClr val="1A1A1A"/>
                 </a:solidFill>
                 <a:latin typeface="Calibri" pitchFamily="34" charset="0"/>
                 <a:ea typeface="Calibri" pitchFamily="34" charset="-122"/>
                 <a:cs typeface="Calibri" pitchFamily="34" charset="-120"/>
               </a:rPr>
-              <a:t>Collect it for real</a:t>
-            </a:r>
-            <a:endParaRPr lang="en-US" sz="1500" dirty="0"/>
-          </a:p>
-        </p:txBody>
-      </p:sp>
-      <p:sp>
-        <p:nvSpPr>
-          <p:cNvPr id="9" name="Text 7"/>
-          <p:cNvSpPr/>
-          <p:nvPr/>
-        </p:nvSpPr>
-        <p:spPr>
-          <a:xfrm>
-            <a:off x="1051560" y="3611880"/>
-            <a:ext cx="9875520" cy="868680"/>
-          </a:xfrm>
-          <a:prstGeom prst="rect">
-            <a:avLst/>
-          </a:prstGeom>
-          <a:noFill/>
-          <a:ln/>
-        </p:spPr>
-        <p:txBody>
-          <a:bodyPr wrap="square" lIns="0" tIns="0" rIns="0" bIns="0" rtlCol="0" anchor="t"/>
-          <a:lstStyle/>
-          <a:p>
-            <a:pPr indent="0" marL="0">
-              <a:buNone/>
-            </a:pPr>
-            <a:r>
-              <a:rPr lang="en-US" sz="1400" dirty="0">
-                <a:solidFill>
-                  <a:srgbClr val="E8DCD6"/>
+              <a:t>the fields your question uses, not the whole site.</a:t>
+            </a:r>
+            <a:endParaRPr lang="en-US" sz="1350" dirty="0"/>
+          </a:p>
+        </p:txBody>
+      </p:sp>
+      <p:sp>
+        <p:nvSpPr>
+          <p:cNvPr id="13" name="Shape 11"/>
+          <p:cNvSpPr/>
+          <p:nvPr/>
+        </p:nvSpPr>
+        <p:spPr>
+          <a:xfrm>
+            <a:off x="640080" y="5166360"/>
+            <a:ext cx="10881360" cy="914400"/>
+          </a:xfrm>
+          <a:prstGeom prst="roundRect">
+            <a:avLst>
+              <a:gd name="adj" fmla="val 10000"/>
+            </a:avLst>
+          </a:prstGeom>
+          <a:solidFill>
+            <a:srgbClr val="F4EEE8"/>
+          </a:solidFill>
+          <a:ln/>
+        </p:spPr>
+      </p:sp>
+      <p:sp>
+        <p:nvSpPr>
+          <p:cNvPr id="14" name="Text 12"/>
+          <p:cNvSpPr/>
+          <p:nvPr/>
+        </p:nvSpPr>
+        <p:spPr>
+          <a:xfrm>
+            <a:off x="960120" y="5257800"/>
+            <a:ext cx="4023360" cy="731520"/>
+          </a:xfrm>
+          <a:prstGeom prst="rect">
+            <a:avLst/>
+          </a:prstGeom>
+          <a:noFill/>
+          <a:ln/>
+        </p:spPr>
+        <p:txBody>
+          <a:bodyPr wrap="square" lIns="0" tIns="0" rIns="0" bIns="0" rtlCol="0" anchor="ctr"/>
+          <a:lstStyle/>
+          <a:p>
+            <a:pPr indent="0" marL="0">
+              <a:buNone/>
+            </a:pPr>
+            <a:r>
+              <a:rPr lang="en-US" sz="1700" b="1" dirty="0">
+                <a:solidFill>
+                  <a:srgbClr val="2E5F8A"/>
+                </a:solidFill>
+                <a:latin typeface="Cambria" pitchFamily="34" charset="0"/>
+                <a:ea typeface="Cambria" pitchFamily="34" charset="-122"/>
+                <a:cs typeface="Cambria" pitchFamily="34" charset="-120"/>
+              </a:rPr>
+              <a:t>Never republish the text</a:t>
+            </a:r>
+            <a:endParaRPr lang="en-US" sz="1700" dirty="0"/>
+          </a:p>
+        </p:txBody>
+      </p:sp>
+      <p:sp>
+        <p:nvSpPr>
+          <p:cNvPr id="15" name="Text 13"/>
+          <p:cNvSpPr/>
+          <p:nvPr/>
+        </p:nvSpPr>
+        <p:spPr>
+          <a:xfrm>
+            <a:off x="5120640" y="5257800"/>
+            <a:ext cx="6126480" cy="731520"/>
+          </a:xfrm>
+          <a:prstGeom prst="rect">
+            <a:avLst/>
+          </a:prstGeom>
+          <a:noFill/>
+          <a:ln/>
+        </p:spPr>
+        <p:txBody>
+          <a:bodyPr wrap="square" lIns="0" tIns="0" rIns="0" bIns="0" rtlCol="0" anchor="ctr"/>
+          <a:lstStyle/>
+          <a:p>
+            <a:pPr indent="0" marL="0">
+              <a:buNone/>
+            </a:pPr>
+            <a:r>
+              <a:rPr lang="en-US" sz="1350" dirty="0">
+                <a:solidFill>
+                  <a:srgbClr val="1A1A1A"/>
                 </a:solidFill>
                 <a:latin typeface="Calibri" pitchFamily="34" charset="0"/>
                 <a:ea typeface="Calibri" pitchFamily="34" charset="-122"/>
                 <a:cs typeface="Calibri" pitchFamily="34" charset="-120"/>
               </a:rPr>
-              <a:t>The cookbook notebook, and leave the file in Drive. Week 5 begins there.</a:t>
-            </a:r>
-            <a:endParaRPr lang="en-US" sz="1400" dirty="0"/>
-          </a:p>
-        </p:txBody>
-      </p:sp>
-      <p:sp>
-        <p:nvSpPr>
-          <p:cNvPr id="10" name="Shape 8"/>
-          <p:cNvSpPr/>
-          <p:nvPr/>
-        </p:nvSpPr>
-        <p:spPr>
-          <a:xfrm>
-            <a:off x="640080" y="4709160"/>
-            <a:ext cx="219456" cy="219456"/>
-          </a:xfrm>
-          <a:prstGeom prst="ellipse">
-            <a:avLst/>
-          </a:prstGeom>
-          <a:solidFill>
-            <a:srgbClr val="E8DCD6"/>
-          </a:solidFill>
-          <a:ln/>
-        </p:spPr>
-      </p:sp>
-      <p:sp>
-        <p:nvSpPr>
-          <p:cNvPr id="11" name="Text 9"/>
-          <p:cNvSpPr/>
-          <p:nvPr/>
-        </p:nvSpPr>
-        <p:spPr>
-          <a:xfrm>
-            <a:off x="1051560" y="4572000"/>
-            <a:ext cx="10058400" cy="365760"/>
-          </a:xfrm>
-          <a:prstGeom prst="rect">
-            <a:avLst/>
-          </a:prstGeom>
-          <a:noFill/>
-          <a:ln/>
-        </p:spPr>
-        <p:txBody>
-          <a:bodyPr wrap="square" lIns="0" tIns="0" rIns="0" bIns="0" rtlCol="0" anchor="ctr"/>
-          <a:lstStyle/>
-          <a:p>
-            <a:pPr indent="0" marL="0">
-              <a:buNone/>
-            </a:pPr>
-            <a:r>
-              <a:rPr lang="en-US" sz="1500" b="1" dirty="0">
-                <a:solidFill>
-                  <a:srgbClr val="E8DCD6"/>
+              <a:t>analyse it, quote it, count it. Do not hand it on.</a:t>
+            </a:r>
+            <a:endParaRPr lang="en-US" sz="1350" dirty="0"/>
+          </a:p>
+        </p:txBody>
+      </p:sp>
+      <p:sp>
+        <p:nvSpPr>
+          <p:cNvPr id="16" name="Text 14"/>
+          <p:cNvSpPr/>
+          <p:nvPr/>
+        </p:nvSpPr>
+        <p:spPr>
+          <a:xfrm>
+            <a:off x="640080" y="6309360"/>
+            <a:ext cx="10881360" cy="365760"/>
+          </a:xfrm>
+          <a:prstGeom prst="rect">
+            <a:avLst/>
+          </a:prstGeom>
+          <a:noFill/>
+          <a:ln/>
+        </p:spPr>
+        <p:txBody>
+          <a:bodyPr wrap="square" rtlCol="0" anchor="ctr"/>
+          <a:lstStyle/>
+          <a:p>
+            <a:pPr indent="0" marL="0">
+              <a:buNone/>
+            </a:pPr>
+            <a:r>
+              <a:rPr lang="en-US" sz="1250" i="1" dirty="0">
+                <a:solidFill>
+                  <a:srgbClr val="6B6B63"/>
                 </a:solidFill>
                 <a:latin typeface="Calibri" pitchFamily="34" charset="0"/>
                 <a:ea typeface="Calibri" pitchFamily="34" charset="-122"/>
                 <a:cs typeface="Calibri" pitchFamily="34" charset="-120"/>
               </a:rPr>
-              <a:t>Play with the map</a:t>
-            </a:r>
-            <a:endParaRPr lang="en-US" sz="1500" dirty="0"/>
-          </a:p>
-        </p:txBody>
-      </p:sp>
-      <p:sp>
-        <p:nvSpPr>
-          <p:cNvPr id="12" name="Text 10"/>
-          <p:cNvSpPr/>
-          <p:nvPr/>
-        </p:nvSpPr>
-        <p:spPr>
-          <a:xfrm>
-            <a:off x="1051560" y="4937760"/>
-            <a:ext cx="9875520" cy="868680"/>
-          </a:xfrm>
-          <a:prstGeom prst="rect">
-            <a:avLst/>
-          </a:prstGeom>
-          <a:noFill/>
-          <a:ln/>
-        </p:spPr>
-        <p:txBody>
-          <a:bodyPr wrap="square" lIns="0" tIns="0" rIns="0" bIns="0" rtlCol="0" anchor="t"/>
-          <a:lstStyle/>
-          <a:p>
-            <a:pPr indent="0" marL="0">
-              <a:buNone/>
-            </a:pPr>
-            <a:r>
-              <a:rPr lang="en-US" sz="1400" dirty="0">
-                <a:solidFill>
-                  <a:srgbClr val="E8DCD6"/>
+              <a:t>CC0 and public domain: go anywhere.   Academic sets and community text: analyse, don't redistribute.   Shadow libraries: never.</a:t>
+            </a:r>
+            <a:endParaRPr lang="en-US" sz="1250" dirty="0"/>
+          </a:p>
+        </p:txBody>
+      </p:sp>
+    </p:spTree>
+  </p:cSld>
+  <p:clrMapOvr>
+    <a:masterClrMapping/>
+  </p:clrMapOvr>
+</p:sld>
+</file>
+
+<file path=ppt/slides/slide29.xml><?xml version="1.0" encoding="utf-8"?>
+<p:sld xmlns:a="http://schemas.openxmlformats.org/drawingml/2006/main" xmlns:r="http://schemas.openxmlformats.org/officeDocument/2006/relationships" xmlns:p="http://schemas.openxmlformats.org/presentationml/2006/main">
+  <p:cSld name="Slide 29">
+    <p:bg>
+      <p:bgPr>
+        <a:solidFill>
+          <a:srgbClr val="FFFFFF"/>
+        </a:solidFill>
+      </p:bgPr>
+    </p:bg>
+    <p:spTree>
+      <p:nvGrpSpPr>
+        <p:cNvPr id="1" name=""/>
+        <p:cNvGrpSpPr/>
+        <p:nvPr/>
+      </p:nvGrpSpPr>
+      <p:grpSpPr>
+        <a:xfrm>
+          <a:off x="0" y="0"/>
+          <a:ext cx="0" cy="0"/>
+          <a:chOff x="0" y="0"/>
+          <a:chExt cx="0" cy="0"/>
+        </a:xfrm>
+      </p:grpSpPr>
+      <p:sp>
+        <p:nvSpPr>
+          <p:cNvPr id="2" name="Text 0"/>
+          <p:cNvSpPr/>
+          <p:nvPr/>
+        </p:nvSpPr>
+        <p:spPr>
+          <a:xfrm>
+            <a:off x="640080" y="502920"/>
+            <a:ext cx="10515600" cy="320040"/>
+          </a:xfrm>
+          <a:prstGeom prst="rect">
+            <a:avLst/>
+          </a:prstGeom>
+          <a:noFill/>
+          <a:ln/>
+        </p:spPr>
+        <p:txBody>
+          <a:bodyPr wrap="square" rtlCol="0" anchor="ctr"/>
+          <a:lstStyle/>
+          <a:p>
+            <a:pPr indent="0" marL="0">
+              <a:buNone/>
+            </a:pPr>
+            <a:r>
+              <a:rPr lang="en-US" sz="1300" b="1" spc="300" kern="0" dirty="0">
+                <a:solidFill>
+                  <a:srgbClr val="7A3B2E"/>
                 </a:solidFill>
                 <a:latin typeface="Calibri" pitchFamily="34" charset="0"/>
                 <a:ea typeface="Calibri" pitchFamily="34" charset="-122"/>
                 <a:cs typeface="Calibri" pitchFamily="34" charset="-120"/>
               </a:rPr>
-              <a:t>Embedding Projector: a word from your corpus, one neighbour that makes sense and one that does not.</a:t>
-            </a:r>
-            <a:endParaRPr lang="en-US" sz="1400" dirty="0"/>
-          </a:p>
-        </p:txBody>
-      </p:sp>
-      <p:sp>
-        <p:nvSpPr>
-          <p:cNvPr id="13" name="Text 11"/>
-          <p:cNvSpPr/>
-          <p:nvPr/>
-        </p:nvSpPr>
-        <p:spPr>
-          <a:xfrm>
-            <a:off x="640080" y="6035040"/>
-            <a:ext cx="10881360" cy="457200"/>
+              <a:t>ROUTE THREE, IN PRACTICE</a:t>
+            </a:r>
+            <a:endParaRPr lang="en-US" sz="1300" dirty="0"/>
+          </a:p>
+        </p:txBody>
+      </p:sp>
+      <p:sp>
+        <p:nvSpPr>
+          <p:cNvPr id="3" name="Text 1"/>
+          <p:cNvSpPr/>
+          <p:nvPr/>
+        </p:nvSpPr>
+        <p:spPr>
+          <a:xfrm>
+            <a:off x="640080" y="868680"/>
+            <a:ext cx="10972800" cy="777240"/>
+          </a:xfrm>
+          <a:prstGeom prst="rect">
+            <a:avLst/>
+          </a:prstGeom>
+          <a:noFill/>
+          <a:ln/>
+        </p:spPr>
+        <p:txBody>
+          <a:bodyPr wrap="square" rtlCol="0" anchor="t"/>
+          <a:lstStyle/>
+          <a:p>
+            <a:pPr indent="0" marL="0">
+              <a:buNone/>
+            </a:pPr>
+            <a:r>
+              <a:rPr lang="en-US" sz="3400" b="1" dirty="0">
+                <a:solidFill>
+                  <a:srgbClr val="1A1A1A"/>
+                </a:solidFill>
+                <a:latin typeface="Cambria" pitchFamily="34" charset="0"/>
+                <a:ea typeface="Cambria" pitchFamily="34" charset="-122"/>
+                <a:cs typeface="Cambria" pitchFamily="34" charset="-120"/>
+              </a:rPr>
+              <a:t>Find the data inside the markup</a:t>
+            </a:r>
+            <a:endParaRPr lang="en-US" sz="3400" dirty="0"/>
+          </a:p>
+        </p:txBody>
+      </p:sp>
+      <p:pic>
+        <p:nvPicPr>
+          <p:cNvPr id="4" name="Image 0" descr="/tmp/figs/w4_scrape_anatomy.png">    </p:cNvPr>
+          <p:cNvPicPr>
+            <a:picLocks noChangeAspect="1"/>
+          </p:cNvPicPr>
+          <p:nvPr/>
+        </p:nvPicPr>
+        <p:blipFill>
+          <a:blip r:embed="rId1"/>
+          <a:srcRect l="0" r="0" t="0" b="0"/>
+          <a:stretch/>
+        </p:blipFill>
+        <p:spPr>
+          <a:xfrm>
+            <a:off x="640080" y="1874520"/>
+            <a:ext cx="10881360" cy="3566160"/>
+          </a:xfrm>
+          <a:prstGeom prst="rect">
+            <a:avLst/>
+          </a:prstGeom>
+        </p:spPr>
+      </p:pic>
+      <p:sp>
+        <p:nvSpPr>
+          <p:cNvPr id="5" name="Text 2"/>
+          <p:cNvSpPr/>
+          <p:nvPr/>
+        </p:nvSpPr>
+        <p:spPr>
+          <a:xfrm>
+            <a:off x="640080" y="5897880"/>
+            <a:ext cx="10881360" cy="411480"/>
           </a:xfrm>
           <a:prstGeom prst="rect">
             <a:avLst/>
@@ -9930,17 +9988,56 @@
               <a:buNone/>
             </a:pPr>
             <a:r>
-              <a:rPr lang="en-US" sz="1300" i="1" dirty="0">
-                <a:solidFill>
-                  <a:srgbClr val="B9852F"/>
+              <a:rPr lang="en-US" sz="1600" i="1" dirty="0">
+                <a:solidFill>
+                  <a:srgbClr val="1A1A1A"/>
+                </a:solidFill>
+                <a:latin typeface="Cambria" pitchFamily="34" charset="0"/>
+                <a:ea typeface="Cambria" pitchFamily="34" charset="-122"/>
+                <a:cs typeface="Cambria" pitchFamily="34" charset="-120"/>
+              </a:rPr>
+              <a:t>Fetch one page, look at one block, and read the selectors off it. Right-click, Inspect, and the tag names are right there.</a:t>
+            </a:r>
+            <a:endParaRPr lang="en-US" sz="1600" dirty="0"/>
+          </a:p>
+        </p:txBody>
+      </p:sp>
+      <p:sp>
+        <p:nvSpPr>
+          <p:cNvPr id="6" name="Text 3"/>
+          <p:cNvSpPr/>
+          <p:nvPr/>
+        </p:nvSpPr>
+        <p:spPr>
+          <a:xfrm>
+            <a:off x="640080" y="6355080"/>
+            <a:ext cx="10881360" cy="320040"/>
+          </a:xfrm>
+          <a:prstGeom prst="rect">
+            <a:avLst/>
+          </a:prstGeom>
+          <a:noFill/>
+          <a:ln/>
+        </p:spPr>
+        <p:txBody>
+          <a:bodyPr wrap="square" rtlCol="0" anchor="ctr"/>
+          <a:lstStyle/>
+          <a:p>
+            <a:pPr indent="0" marL="0">
+              <a:buNone/>
+            </a:pPr>
+            <a:r>
+              <a:rPr lang="en-US" sz="1000" dirty="0">
+                <a:solidFill>
+                  <a:srgbClr val="6B6B63"/>
                 </a:solidFill>
                 <a:latin typeface="Calibri" pitchFamily="34" charset="0"/>
                 <a:ea typeface="Calibri" pitchFamily="34" charset="-122"/>
                 <a:cs typeface="Calibri" pitchFamily="34" charset="-120"/>
               </a:rPr>
-              <a:t>Next week: embeddings on YOUR corpus, all session. Bring the file.</a:t>
-            </a:r>
-            <a:endParaRPr lang="en-US" sz="1300" dirty="0"/>
+              <a:t>Real HTML from quotes.toscrape.com. A selector that matches nothing returns None and raises no error, which is the bug you will actually hit.</a:t>
+            </a:r>
+            <a:endParaRPr lang="en-US" sz="1000" dirty="0"/>
           </a:p>
         </p:txBody>
       </p:sp>
@@ -10152,6 +10249,1109 @@
               <a:t>Fig. 1b, Garg, Schiebinger, Jurafsky &amp; Zou, PNAS 2018 (arXiv:1711.08412) · shown for teaching</a:t>
             </a:r>
             <a:endParaRPr lang="en-US" sz="1000" dirty="0"/>
+          </a:p>
+        </p:txBody>
+      </p:sp>
+    </p:spTree>
+  </p:cSld>
+  <p:clrMapOvr>
+    <a:masterClrMapping/>
+  </p:clrMapOvr>
+</p:sld>
+</file>
+
+<file path=ppt/slides/slide30.xml><?xml version="1.0" encoding="utf-8"?>
+<p:sld xmlns:a="http://schemas.openxmlformats.org/drawingml/2006/main" xmlns:r="http://schemas.openxmlformats.org/officeDocument/2006/relationships" xmlns:p="http://schemas.openxmlformats.org/presentationml/2006/main">
+  <p:cSld name="Slide 30">
+    <p:bg>
+      <p:bgPr>
+        <a:solidFill>
+          <a:srgbClr val="FFFFFF"/>
+        </a:solidFill>
+      </p:bgPr>
+    </p:bg>
+    <p:spTree>
+      <p:nvGrpSpPr>
+        <p:cNvPr id="1" name=""/>
+        <p:cNvGrpSpPr/>
+        <p:nvPr/>
+      </p:nvGrpSpPr>
+      <p:grpSpPr>
+        <a:xfrm>
+          <a:off x="0" y="0"/>
+          <a:ext cx="0" cy="0"/>
+          <a:chOff x="0" y="0"/>
+          <a:chExt cx="0" cy="0"/>
+        </a:xfrm>
+      </p:grpSpPr>
+      <p:sp>
+        <p:nvSpPr>
+          <p:cNvPr id="2" name="Text 0"/>
+          <p:cNvSpPr/>
+          <p:nvPr/>
+        </p:nvSpPr>
+        <p:spPr>
+          <a:xfrm>
+            <a:off x="640080" y="502920"/>
+            <a:ext cx="10515600" cy="320040"/>
+          </a:xfrm>
+          <a:prstGeom prst="rect">
+            <a:avLst/>
+          </a:prstGeom>
+          <a:noFill/>
+          <a:ln/>
+        </p:spPr>
+        <p:txBody>
+          <a:bodyPr wrap="square" rtlCol="0" anchor="ctr"/>
+          <a:lstStyle/>
+          <a:p>
+            <a:pPr indent="0" marL="0">
+              <a:buNone/>
+            </a:pPr>
+            <a:r>
+              <a:rPr lang="en-US" sz="1300" b="1" spc="300" kern="0" dirty="0">
+                <a:solidFill>
+                  <a:srgbClr val="B9852F"/>
+                </a:solidFill>
+                <a:latin typeface="Calibri" pitchFamily="34" charset="0"/>
+                <a:ea typeface="Calibri" pitchFamily="34" charset="-122"/>
+                <a:cs typeface="Calibri" pitchFamily="34" charset="-120"/>
+              </a:rPr>
+              <a:t>BEFORE YOU START IT RUNNING</a:t>
+            </a:r>
+            <a:endParaRPr lang="en-US" sz="1300" dirty="0"/>
+          </a:p>
+        </p:txBody>
+      </p:sp>
+      <p:sp>
+        <p:nvSpPr>
+          <p:cNvPr id="3" name="Text 1"/>
+          <p:cNvSpPr/>
+          <p:nvPr/>
+        </p:nvSpPr>
+        <p:spPr>
+          <a:xfrm>
+            <a:off x="640080" y="868680"/>
+            <a:ext cx="10972800" cy="777240"/>
+          </a:xfrm>
+          <a:prstGeom prst="rect">
+            <a:avLst/>
+          </a:prstGeom>
+          <a:noFill/>
+          <a:ln/>
+        </p:spPr>
+        <p:txBody>
+          <a:bodyPr wrap="square" rtlCol="0" anchor="t"/>
+          <a:lstStyle/>
+          <a:p>
+            <a:pPr indent="0" marL="0">
+              <a:buNone/>
+            </a:pPr>
+            <a:r>
+              <a:rPr lang="en-US" sz="3400" b="1" dirty="0">
+                <a:solidFill>
+                  <a:srgbClr val="1A1A1A"/>
+                </a:solidFill>
+                <a:latin typeface="Cambria" pitchFamily="34" charset="0"/>
+                <a:ea typeface="Cambria" pitchFamily="34" charset="-122"/>
+                <a:cs typeface="Cambria" pitchFamily="34" charset="-120"/>
+              </a:rPr>
+              <a:t>How long will this take?</a:t>
+            </a:r>
+            <a:endParaRPr lang="en-US" sz="3400" dirty="0"/>
+          </a:p>
+        </p:txBody>
+      </p:sp>
+      <p:pic>
+        <p:nvPicPr>
+          <p:cNvPr id="4" name="Image 0" descr="/tmp/figs/w4_scrape_cost.png">    </p:cNvPr>
+          <p:cNvPicPr>
+            <a:picLocks noChangeAspect="1"/>
+          </p:cNvPicPr>
+          <p:nvPr/>
+        </p:nvPicPr>
+        <p:blipFill>
+          <a:blip r:embed="rId1"/>
+          <a:srcRect l="0" r="0" t="0" b="0"/>
+          <a:stretch/>
+        </p:blipFill>
+        <p:spPr>
+          <a:xfrm>
+            <a:off x="2103120" y="1783080"/>
+            <a:ext cx="7955280" cy="3931920"/>
+          </a:xfrm>
+          <a:prstGeom prst="rect">
+            <a:avLst/>
+          </a:prstGeom>
+        </p:spPr>
+      </p:pic>
+      <p:sp>
+        <p:nvSpPr>
+          <p:cNvPr id="5" name="Text 2"/>
+          <p:cNvSpPr/>
+          <p:nvPr/>
+        </p:nvSpPr>
+        <p:spPr>
+          <a:xfrm>
+            <a:off x="640080" y="5897880"/>
+            <a:ext cx="10881360" cy="411480"/>
+          </a:xfrm>
+          <a:prstGeom prst="rect">
+            <a:avLst/>
+          </a:prstGeom>
+          <a:noFill/>
+          <a:ln/>
+        </p:spPr>
+        <p:txBody>
+          <a:bodyPr wrap="square" rtlCol="0" anchor="ctr"/>
+          <a:lstStyle/>
+          <a:p>
+            <a:pPr indent="0" marL="0">
+              <a:buNone/>
+            </a:pPr>
+            <a:r>
+              <a:rPr lang="en-US" sz="1600" i="1" dirty="0">
+                <a:solidFill>
+                  <a:srgbClr val="1A1A1A"/>
+                </a:solidFill>
+                <a:latin typeface="Cambria" pitchFamily="34" charset="0"/>
+                <a:ea typeface="Cambria" pitchFamily="34" charset="-122"/>
+                <a:cs typeface="Cambria" pitchFamily="34" charset="-120"/>
+              </a:rPr>
+              <a:t>A one-second pause on 5,000 pages is an hour and a half. That number decides your sample size, so work it out first.</a:t>
+            </a:r>
+            <a:endParaRPr lang="en-US" sz="1600" dirty="0"/>
+          </a:p>
+        </p:txBody>
+      </p:sp>
+      <p:sp>
+        <p:nvSpPr>
+          <p:cNvPr id="6" name="Text 3"/>
+          <p:cNvSpPr/>
+          <p:nvPr/>
+        </p:nvSpPr>
+        <p:spPr>
+          <a:xfrm>
+            <a:off x="640080" y="6355080"/>
+            <a:ext cx="10881360" cy="320040"/>
+          </a:xfrm>
+          <a:prstGeom prst="rect">
+            <a:avLst/>
+          </a:prstGeom>
+          <a:noFill/>
+          <a:ln/>
+        </p:spPr>
+        <p:txBody>
+          <a:bodyPr wrap="square" rtlCol="0" anchor="ctr"/>
+          <a:lstStyle/>
+          <a:p>
+            <a:pPr indent="0" marL="0">
+              <a:buNone/>
+            </a:pPr>
+            <a:r>
+              <a:rPr lang="en-US" sz="1000" dirty="0">
+                <a:solidFill>
+                  <a:srgbClr val="6B6B63"/>
+                </a:solidFill>
+                <a:latin typeface="Calibri" pitchFamily="34" charset="0"/>
+                <a:ea typeface="Calibri" pitchFamily="34" charset="-122"/>
+                <a:cs typeface="Calibri" pitchFamily="34" charset="-120"/>
+              </a:rPr>
+              <a:t>And the site notices the difference. One page a second is a reader; fifty a second is an outage.</a:t>
+            </a:r>
+            <a:endParaRPr lang="en-US" sz="1000" dirty="0"/>
+          </a:p>
+        </p:txBody>
+      </p:sp>
+    </p:spTree>
+  </p:cSld>
+  <p:clrMapOvr>
+    <a:masterClrMapping/>
+  </p:clrMapOvr>
+</p:sld>
+</file>
+
+<file path=ppt/slides/slide31.xml><?xml version="1.0" encoding="utf-8"?>
+<p:sld xmlns:a="http://schemas.openxmlformats.org/drawingml/2006/main" xmlns:r="http://schemas.openxmlformats.org/officeDocument/2006/relationships" xmlns:p="http://schemas.openxmlformats.org/presentationml/2006/main">
+  <p:cSld name="Slide 31">
+    <p:bg>
+      <p:bgPr>
+        <a:solidFill>
+          <a:srgbClr val="FFFFFF"/>
+        </a:solidFill>
+      </p:bgPr>
+    </p:bg>
+    <p:spTree>
+      <p:nvGrpSpPr>
+        <p:cNvPr id="1" name=""/>
+        <p:cNvGrpSpPr/>
+        <p:nvPr/>
+      </p:nvGrpSpPr>
+      <p:grpSpPr>
+        <a:xfrm>
+          <a:off x="0" y="0"/>
+          <a:ext cx="0" cy="0"/>
+          <a:chOff x="0" y="0"/>
+          <a:chExt cx="0" cy="0"/>
+        </a:xfrm>
+      </p:grpSpPr>
+      <p:sp>
+        <p:nvSpPr>
+          <p:cNvPr id="2" name="Text 0"/>
+          <p:cNvSpPr/>
+          <p:nvPr/>
+        </p:nvSpPr>
+        <p:spPr>
+          <a:xfrm>
+            <a:off x="640080" y="502920"/>
+            <a:ext cx="10515600" cy="320040"/>
+          </a:xfrm>
+          <a:prstGeom prst="rect">
+            <a:avLst/>
+          </a:prstGeom>
+          <a:noFill/>
+          <a:ln/>
+        </p:spPr>
+        <p:txBody>
+          <a:bodyPr wrap="square" rtlCol="0" anchor="ctr"/>
+          <a:lstStyle/>
+          <a:p>
+            <a:pPr indent="0" marL="0">
+              <a:buNone/>
+            </a:pPr>
+            <a:r>
+              <a:rPr lang="en-US" sz="1300" b="1" spc="300" kern="0" dirty="0">
+                <a:solidFill>
+                  <a:srgbClr val="3F6F5F"/>
+                </a:solidFill>
+                <a:latin typeface="Calibri" pitchFamily="34" charset="0"/>
+                <a:ea typeface="Calibri" pitchFamily="34" charset="-122"/>
+                <a:cs typeface="Calibri" pitchFamily="34" charset="-120"/>
+              </a:rPr>
+              <a:t>YOUR TURN · 20 MINUTES</a:t>
+            </a:r>
+            <a:endParaRPr lang="en-US" sz="1300" dirty="0"/>
+          </a:p>
+        </p:txBody>
+      </p:sp>
+      <p:sp>
+        <p:nvSpPr>
+          <p:cNvPr id="3" name="Text 1"/>
+          <p:cNvSpPr/>
+          <p:nvPr/>
+        </p:nvSpPr>
+        <p:spPr>
+          <a:xfrm>
+            <a:off x="640080" y="868680"/>
+            <a:ext cx="10972800" cy="777240"/>
+          </a:xfrm>
+          <a:prstGeom prst="rect">
+            <a:avLst/>
+          </a:prstGeom>
+          <a:noFill/>
+          <a:ln/>
+        </p:spPr>
+        <p:txBody>
+          <a:bodyPr wrap="square" rtlCol="0" anchor="t"/>
+          <a:lstStyle/>
+          <a:p>
+            <a:pPr indent="0" marL="0">
+              <a:buNone/>
+            </a:pPr>
+            <a:r>
+              <a:rPr lang="en-US" sz="3400" b="1" dirty="0">
+                <a:solidFill>
+                  <a:srgbClr val="1A1A1A"/>
+                </a:solidFill>
+                <a:latin typeface="Cambria" pitchFamily="34" charset="0"/>
+                <a:ea typeface="Cambria" pitchFamily="34" charset="-122"/>
+                <a:cs typeface="Cambria" pitchFamily="34" charset="-120"/>
+              </a:rPr>
+              <a:t>Collect it, save it, start the repo</a:t>
+            </a:r>
+            <a:endParaRPr lang="en-US" sz="3400" dirty="0"/>
+          </a:p>
+        </p:txBody>
+      </p:sp>
+      <p:sp>
+        <p:nvSpPr>
+          <p:cNvPr id="4" name="Shape 2"/>
+          <p:cNvSpPr/>
+          <p:nvPr/>
+        </p:nvSpPr>
+        <p:spPr>
+          <a:xfrm>
+            <a:off x="640080" y="2103120"/>
+            <a:ext cx="10881360" cy="1097280"/>
+          </a:xfrm>
+          <a:prstGeom prst="roundRect">
+            <a:avLst>
+              <a:gd name="adj" fmla="val 8333"/>
+            </a:avLst>
+          </a:prstGeom>
+          <a:solidFill>
+            <a:srgbClr val="F4EEE8"/>
+          </a:solidFill>
+          <a:ln/>
+        </p:spPr>
+      </p:sp>
+      <p:sp>
+        <p:nvSpPr>
+          <p:cNvPr id="5" name="Text 3"/>
+          <p:cNvSpPr/>
+          <p:nvPr/>
+        </p:nvSpPr>
+        <p:spPr>
+          <a:xfrm>
+            <a:off x="1005840" y="2240280"/>
+            <a:ext cx="4206240" cy="822960"/>
+          </a:xfrm>
+          <a:prstGeom prst="rect">
+            <a:avLst/>
+          </a:prstGeom>
+          <a:noFill/>
+          <a:ln/>
+        </p:spPr>
+        <p:txBody>
+          <a:bodyPr wrap="square" lIns="0" tIns="0" rIns="0" bIns="0" rtlCol="0" anchor="ctr"/>
+          <a:lstStyle/>
+          <a:p>
+            <a:pPr indent="0" marL="0">
+              <a:buNone/>
+            </a:pPr>
+            <a:r>
+              <a:rPr lang="en-US" sz="1900" b="1" dirty="0">
+                <a:solidFill>
+                  <a:srgbClr val="3F6F5F"/>
+                </a:solidFill>
+                <a:latin typeface="Cambria" pitchFamily="34" charset="0"/>
+                <a:ea typeface="Cambria" pitchFamily="34" charset="-122"/>
+                <a:cs typeface="Cambria" pitchFamily="34" charset="-120"/>
+              </a:rPr>
+              <a:t>a file in your Drive folder</a:t>
+            </a:r>
+            <a:endParaRPr lang="en-US" sz="1900" dirty="0"/>
+          </a:p>
+        </p:txBody>
+      </p:sp>
+      <p:sp>
+        <p:nvSpPr>
+          <p:cNvPr id="6" name="Text 4"/>
+          <p:cNvSpPr/>
+          <p:nvPr/>
+        </p:nvSpPr>
+        <p:spPr>
+          <a:xfrm>
+            <a:off x="5394960" y="2240280"/>
+            <a:ext cx="5760720" cy="822960"/>
+          </a:xfrm>
+          <a:prstGeom prst="rect">
+            <a:avLst/>
+          </a:prstGeom>
+          <a:noFill/>
+          <a:ln/>
+        </p:spPr>
+        <p:txBody>
+          <a:bodyPr wrap="square" lIns="0" tIns="0" rIns="0" bIns="0" rtlCol="0" anchor="ctr"/>
+          <a:lstStyle/>
+          <a:p>
+            <a:pPr indent="0" marL="0">
+              <a:buNone/>
+            </a:pPr>
+            <a:r>
+              <a:rPr lang="en-US" sz="1400" dirty="0">
+                <a:solidFill>
+                  <a:srgbClr val="1A1A1A"/>
+                </a:solidFill>
+                <a:latin typeface="Calibri" pitchFamily="34" charset="0"/>
+                <a:ea typeface="Calibri" pitchFamily="34" charset="-122"/>
+                <a:cs typeface="Calibri" pitchFamily="34" charset="-120"/>
+              </a:rPr>
+              <a:t>Week 5 starts from it. Colab forgets everything else.</a:t>
+            </a:r>
+            <a:endParaRPr lang="en-US" sz="1400" dirty="0"/>
+          </a:p>
+        </p:txBody>
+      </p:sp>
+      <p:sp>
+        <p:nvSpPr>
+          <p:cNvPr id="7" name="Shape 5"/>
+          <p:cNvSpPr/>
+          <p:nvPr/>
+        </p:nvSpPr>
+        <p:spPr>
+          <a:xfrm>
+            <a:off x="640080" y="3383280"/>
+            <a:ext cx="10881360" cy="1097280"/>
+          </a:xfrm>
+          <a:prstGeom prst="roundRect">
+            <a:avLst>
+              <a:gd name="adj" fmla="val 8333"/>
+            </a:avLst>
+          </a:prstGeom>
+          <a:solidFill>
+            <a:srgbClr val="F4EEE8"/>
+          </a:solidFill>
+          <a:ln/>
+        </p:spPr>
+      </p:sp>
+      <p:sp>
+        <p:nvSpPr>
+          <p:cNvPr id="8" name="Text 6"/>
+          <p:cNvSpPr/>
+          <p:nvPr/>
+        </p:nvSpPr>
+        <p:spPr>
+          <a:xfrm>
+            <a:off x="1005840" y="3520440"/>
+            <a:ext cx="4206240" cy="822960"/>
+          </a:xfrm>
+          <a:prstGeom prst="rect">
+            <a:avLst/>
+          </a:prstGeom>
+          <a:noFill/>
+          <a:ln/>
+        </p:spPr>
+        <p:txBody>
+          <a:bodyPr wrap="square" lIns="0" tIns="0" rIns="0" bIns="0" rtlCol="0" anchor="ctr"/>
+          <a:lstStyle/>
+          <a:p>
+            <a:pPr indent="0" marL="0">
+              <a:buNone/>
+            </a:pPr>
+            <a:r>
+              <a:rPr lang="en-US" sz="1900" b="1" dirty="0">
+                <a:solidFill>
+                  <a:srgbClr val="2E5F8A"/>
+                </a:solidFill>
+                <a:latin typeface="Cambria" pitchFamily="34" charset="0"/>
+                <a:ea typeface="Cambria" pitchFamily="34" charset="-122"/>
+                <a:cs typeface="Cambria" pitchFamily="34" charset="-120"/>
+              </a:rPr>
+              <a:t>a repo with Pages switched on</a:t>
+            </a:r>
+            <a:endParaRPr lang="en-US" sz="1900" dirty="0"/>
+          </a:p>
+        </p:txBody>
+      </p:sp>
+      <p:sp>
+        <p:nvSpPr>
+          <p:cNvPr id="9" name="Text 7"/>
+          <p:cNvSpPr/>
+          <p:nvPr/>
+        </p:nvSpPr>
+        <p:spPr>
+          <a:xfrm>
+            <a:off x="5394960" y="3520440"/>
+            <a:ext cx="5760720" cy="822960"/>
+          </a:xfrm>
+          <a:prstGeom prst="rect">
+            <a:avLst/>
+          </a:prstGeom>
+          <a:noFill/>
+          <a:ln/>
+        </p:spPr>
+        <p:txBody>
+          <a:bodyPr wrap="square" lIns="0" tIns="0" rIns="0" bIns="0" rtlCol="0" anchor="ctr"/>
+          <a:lstStyle/>
+          <a:p>
+            <a:pPr indent="0" marL="0">
+              <a:buNone/>
+            </a:pPr>
+            <a:r>
+              <a:rPr lang="en-US" sz="1400" dirty="0">
+                <a:solidFill>
+                  <a:srgbClr val="1A1A1A"/>
+                </a:solidFill>
+                <a:latin typeface="Calibri" pitchFamily="34" charset="0"/>
+                <a:ea typeface="Calibri" pitchFamily="34" charset="-122"/>
+                <a:cs typeface="Calibri" pitchFamily="34" charset="-120"/>
+              </a:rPr>
+              <a:t>so a live URL exists today, not in Week 9 under deadline.</a:t>
+            </a:r>
+            <a:endParaRPr lang="en-US" sz="1400" dirty="0"/>
+          </a:p>
+        </p:txBody>
+      </p:sp>
+      <p:sp>
+        <p:nvSpPr>
+          <p:cNvPr id="10" name="Shape 8"/>
+          <p:cNvSpPr/>
+          <p:nvPr/>
+        </p:nvSpPr>
+        <p:spPr>
+          <a:xfrm>
+            <a:off x="640080" y="4663440"/>
+            <a:ext cx="10881360" cy="1097280"/>
+          </a:xfrm>
+          <a:prstGeom prst="roundRect">
+            <a:avLst>
+              <a:gd name="adj" fmla="val 8333"/>
+            </a:avLst>
+          </a:prstGeom>
+          <a:solidFill>
+            <a:srgbClr val="F4EEE8"/>
+          </a:solidFill>
+          <a:ln/>
+        </p:spPr>
+      </p:sp>
+      <p:sp>
+        <p:nvSpPr>
+          <p:cNvPr id="11" name="Text 9"/>
+          <p:cNvSpPr/>
+          <p:nvPr/>
+        </p:nvSpPr>
+        <p:spPr>
+          <a:xfrm>
+            <a:off x="1005840" y="4800600"/>
+            <a:ext cx="4206240" cy="822960"/>
+          </a:xfrm>
+          <a:prstGeom prst="rect">
+            <a:avLst/>
+          </a:prstGeom>
+          <a:noFill/>
+          <a:ln/>
+        </p:spPr>
+        <p:txBody>
+          <a:bodyPr wrap="square" lIns="0" tIns="0" rIns="0" bIns="0" rtlCol="0" anchor="ctr"/>
+          <a:lstStyle/>
+          <a:p>
+            <a:pPr indent="0" marL="0">
+              <a:buNone/>
+            </a:pPr>
+            <a:r>
+              <a:rPr lang="en-US" sz="1900" b="1" dirty="0">
+                <a:solidFill>
+                  <a:srgbClr val="7A3B2E"/>
+                </a:solidFill>
+                <a:latin typeface="Cambria" pitchFamily="34" charset="0"/>
+                <a:ea typeface="Cambria" pitchFamily="34" charset="-122"/>
+                <a:cs typeface="Cambria" pitchFamily="34" charset="-120"/>
+              </a:rPr>
+              <a:t>two minutes of pitch, to a partner</a:t>
+            </a:r>
+            <a:endParaRPr lang="en-US" sz="1900" dirty="0"/>
+          </a:p>
+        </p:txBody>
+      </p:sp>
+      <p:sp>
+        <p:nvSpPr>
+          <p:cNvPr id="12" name="Text 10"/>
+          <p:cNvSpPr/>
+          <p:nvPr/>
+        </p:nvSpPr>
+        <p:spPr>
+          <a:xfrm>
+            <a:off x="5394960" y="4800600"/>
+            <a:ext cx="5760720" cy="822960"/>
+          </a:xfrm>
+          <a:prstGeom prst="rect">
+            <a:avLst/>
+          </a:prstGeom>
+          <a:noFill/>
+          <a:ln/>
+        </p:spPr>
+        <p:txBody>
+          <a:bodyPr wrap="square" lIns="0" tIns="0" rIns="0" bIns="0" rtlCol="0" anchor="ctr"/>
+          <a:lstStyle/>
+          <a:p>
+            <a:pPr indent="0" marL="0">
+              <a:buNone/>
+            </a:pPr>
+            <a:r>
+              <a:rPr lang="en-US" sz="1400" dirty="0">
+                <a:solidFill>
+                  <a:srgbClr val="1A1A1A"/>
+                </a:solidFill>
+                <a:latin typeface="Calibri" pitchFamily="34" charset="0"/>
+                <a:ea typeface="Calibri" pitchFamily="34" charset="-122"/>
+                <a:cs typeface="Calibri" pitchFamily="34" charset="-120"/>
+              </a:rPr>
+              <a:t>corpus, two methods, what would count as a finding.</a:t>
+            </a:r>
+            <a:endParaRPr lang="en-US" sz="1400" dirty="0"/>
+          </a:p>
+        </p:txBody>
+      </p:sp>
+      <p:sp>
+        <p:nvSpPr>
+          <p:cNvPr id="13" name="Text 11"/>
+          <p:cNvSpPr/>
+          <p:nvPr/>
+        </p:nvSpPr>
+        <p:spPr>
+          <a:xfrm>
+            <a:off x="640080" y="6263640"/>
+            <a:ext cx="10881360" cy="365760"/>
+          </a:xfrm>
+          <a:prstGeom prst="rect">
+            <a:avLst/>
+          </a:prstGeom>
+          <a:noFill/>
+          <a:ln/>
+        </p:spPr>
+        <p:txBody>
+          <a:bodyPr wrap="square" rtlCol="0" anchor="ctr"/>
+          <a:lstStyle/>
+          <a:p>
+            <a:pPr indent="0" marL="0">
+              <a:buNone/>
+            </a:pPr>
+            <a:r>
+              <a:rPr lang="en-US" sz="1100" i="1" dirty="0">
+                <a:solidFill>
+                  <a:srgbClr val="6B6B63"/>
+                </a:solidFill>
+                <a:latin typeface="Calibri" pitchFamily="34" charset="0"/>
+                <a:ea typeface="Calibri" pitchFamily="34" charset="-122"/>
+                <a:cs typeface="Calibri" pitchFamily="34" charset="-120"/>
+              </a:rPr>
+              <a:t>A null result, honestly shown, is a complete project. The pivot kit is insurance, not a demotion.</a:t>
+            </a:r>
+            <a:endParaRPr lang="en-US" sz="1100" dirty="0"/>
+          </a:p>
+        </p:txBody>
+      </p:sp>
+    </p:spTree>
+  </p:cSld>
+  <p:clrMapOvr>
+    <a:masterClrMapping/>
+  </p:clrMapOvr>
+</p:sld>
+</file>
+
+<file path=ppt/slides/slide32.xml><?xml version="1.0" encoding="utf-8"?>
+<p:sld xmlns:a="http://schemas.openxmlformats.org/drawingml/2006/main" xmlns:r="http://schemas.openxmlformats.org/officeDocument/2006/relationships" xmlns:p="http://schemas.openxmlformats.org/presentationml/2006/main">
+  <p:cSld name="Slide 32">
+    <p:bg>
+      <p:bgPr>
+        <a:solidFill>
+          <a:srgbClr val="4E261D"/>
+        </a:solidFill>
+      </p:bgPr>
+    </p:bg>
+    <p:spTree>
+      <p:nvGrpSpPr>
+        <p:cNvPr id="1" name=""/>
+        <p:cNvGrpSpPr/>
+        <p:nvPr/>
+      </p:nvGrpSpPr>
+      <p:grpSpPr>
+        <a:xfrm>
+          <a:off x="0" y="0"/>
+          <a:ext cx="0" cy="0"/>
+          <a:chOff x="0" y="0"/>
+          <a:chExt cx="0" cy="0"/>
+        </a:xfrm>
+      </p:grpSpPr>
+      <p:sp>
+        <p:nvSpPr>
+          <p:cNvPr id="2" name="Text 0"/>
+          <p:cNvSpPr/>
+          <p:nvPr/>
+        </p:nvSpPr>
+        <p:spPr>
+          <a:xfrm>
+            <a:off x="640080" y="502920"/>
+            <a:ext cx="10515600" cy="320040"/>
+          </a:xfrm>
+          <a:prstGeom prst="rect">
+            <a:avLst/>
+          </a:prstGeom>
+          <a:noFill/>
+          <a:ln/>
+        </p:spPr>
+        <p:txBody>
+          <a:bodyPr wrap="square" rtlCol="0" anchor="ctr"/>
+          <a:lstStyle/>
+          <a:p>
+            <a:pPr indent="0" marL="0">
+              <a:buNone/>
+            </a:pPr>
+            <a:r>
+              <a:rPr lang="en-US" sz="1300" b="1" spc="300" kern="0" dirty="0">
+                <a:solidFill>
+                  <a:srgbClr val="B9852F"/>
+                </a:solidFill>
+                <a:latin typeface="Calibri" pitchFamily="34" charset="0"/>
+                <a:ea typeface="Calibri" pitchFamily="34" charset="-122"/>
+                <a:cs typeface="Calibri" pitchFamily="34" charset="-120"/>
+              </a:rPr>
+              <a:t>BEFORE WEEK 5</a:t>
+            </a:r>
+            <a:endParaRPr lang="en-US" sz="1300" dirty="0"/>
+          </a:p>
+        </p:txBody>
+      </p:sp>
+      <p:sp>
+        <p:nvSpPr>
+          <p:cNvPr id="3" name="Text 1"/>
+          <p:cNvSpPr/>
+          <p:nvPr/>
+        </p:nvSpPr>
+        <p:spPr>
+          <a:xfrm>
+            <a:off x="640080" y="914400"/>
+            <a:ext cx="10058400" cy="731520"/>
+          </a:xfrm>
+          <a:prstGeom prst="rect">
+            <a:avLst/>
+          </a:prstGeom>
+          <a:noFill/>
+          <a:ln/>
+        </p:spPr>
+        <p:txBody>
+          <a:bodyPr wrap="square" rtlCol="0" anchor="ctr"/>
+          <a:lstStyle/>
+          <a:p>
+            <a:pPr indent="0" marL="0">
+              <a:buNone/>
+            </a:pPr>
+            <a:r>
+              <a:rPr lang="en-US" sz="3400" b="1" dirty="0">
+                <a:solidFill>
+                  <a:srgbClr val="FFFFFF"/>
+                </a:solidFill>
+                <a:latin typeface="Cambria" pitchFamily="34" charset="0"/>
+                <a:ea typeface="Cambria" pitchFamily="34" charset="-122"/>
+                <a:cs typeface="Cambria" pitchFamily="34" charset="-120"/>
+              </a:rPr>
+              <a:t>Homework</a:t>
+            </a:r>
+            <a:endParaRPr lang="en-US" sz="3400" dirty="0"/>
+          </a:p>
+        </p:txBody>
+      </p:sp>
+      <p:sp>
+        <p:nvSpPr>
+          <p:cNvPr id="4" name="Shape 2"/>
+          <p:cNvSpPr/>
+          <p:nvPr/>
+        </p:nvSpPr>
+        <p:spPr>
+          <a:xfrm>
+            <a:off x="640080" y="2057400"/>
+            <a:ext cx="219456" cy="219456"/>
+          </a:xfrm>
+          <a:prstGeom prst="ellipse">
+            <a:avLst/>
+          </a:prstGeom>
+          <a:solidFill>
+            <a:srgbClr val="B9852F"/>
+          </a:solidFill>
+          <a:ln/>
+        </p:spPr>
+      </p:sp>
+      <p:sp>
+        <p:nvSpPr>
+          <p:cNvPr id="5" name="Text 3"/>
+          <p:cNvSpPr/>
+          <p:nvPr/>
+        </p:nvSpPr>
+        <p:spPr>
+          <a:xfrm>
+            <a:off x="1051560" y="1920240"/>
+            <a:ext cx="10058400" cy="365760"/>
+          </a:xfrm>
+          <a:prstGeom prst="rect">
+            <a:avLst/>
+          </a:prstGeom>
+          <a:noFill/>
+          <a:ln/>
+        </p:spPr>
+        <p:txBody>
+          <a:bodyPr wrap="square" lIns="0" tIns="0" rIns="0" bIns="0" rtlCol="0" anchor="ctr"/>
+          <a:lstStyle/>
+          <a:p>
+            <a:pPr indent="0" marL="0">
+              <a:buNone/>
+            </a:pPr>
+            <a:r>
+              <a:rPr lang="en-US" sz="1500" b="1" dirty="0">
+                <a:solidFill>
+                  <a:srgbClr val="B9852F"/>
+                </a:solidFill>
+                <a:latin typeface="Calibri" pitchFamily="34" charset="0"/>
+                <a:ea typeface="Calibri" pitchFamily="34" charset="-122"/>
+                <a:cs typeface="Calibri" pitchFamily="34" charset="-120"/>
+              </a:rPr>
+              <a:t>Data Biography</a:t>
+            </a:r>
+            <a:endParaRPr lang="en-US" sz="1500" dirty="0"/>
+          </a:p>
+        </p:txBody>
+      </p:sp>
+      <p:sp>
+        <p:nvSpPr>
+          <p:cNvPr id="6" name="Text 4"/>
+          <p:cNvSpPr/>
+          <p:nvPr/>
+        </p:nvSpPr>
+        <p:spPr>
+          <a:xfrm>
+            <a:off x="1051560" y="2286000"/>
+            <a:ext cx="9875520" cy="868680"/>
+          </a:xfrm>
+          <a:prstGeom prst="rect">
+            <a:avLst/>
+          </a:prstGeom>
+          <a:noFill/>
+          <a:ln/>
+        </p:spPr>
+        <p:txBody>
+          <a:bodyPr wrap="square" lIns="0" tIns="0" rIns="0" bIns="0" rtlCol="0" anchor="t"/>
+          <a:lstStyle/>
+          <a:p>
+            <a:pPr indent="0" marL="0">
+              <a:buNone/>
+            </a:pPr>
+            <a:r>
+              <a:rPr lang="en-US" sz="1400" dirty="0">
+                <a:solidFill>
+                  <a:srgbClr val="E8DCD6"/>
+                </a:solidFill>
+                <a:latin typeface="Calibri" pitchFamily="34" charset="0"/>
+                <a:ea typeface="Calibri" pitchFamily="34" charset="-122"/>
+                <a:cs typeface="Calibri" pitchFamily="34" charset="-120"/>
+              </a:rPr>
+              <a:t>~400 words: where it came from, who is in it, who is missing, what it cannot tell you.</a:t>
+            </a:r>
+            <a:endParaRPr lang="en-US" sz="1400" dirty="0"/>
+          </a:p>
+        </p:txBody>
+      </p:sp>
+      <p:sp>
+        <p:nvSpPr>
+          <p:cNvPr id="7" name="Shape 5"/>
+          <p:cNvSpPr/>
+          <p:nvPr/>
+        </p:nvSpPr>
+        <p:spPr>
+          <a:xfrm>
+            <a:off x="640080" y="3383280"/>
+            <a:ext cx="219456" cy="219456"/>
+          </a:xfrm>
+          <a:prstGeom prst="ellipse">
+            <a:avLst/>
+          </a:prstGeom>
+          <a:solidFill>
+            <a:srgbClr val="3F6F5F"/>
+          </a:solidFill>
+          <a:ln/>
+        </p:spPr>
+      </p:sp>
+      <p:sp>
+        <p:nvSpPr>
+          <p:cNvPr id="8" name="Text 6"/>
+          <p:cNvSpPr/>
+          <p:nvPr/>
+        </p:nvSpPr>
+        <p:spPr>
+          <a:xfrm>
+            <a:off x="1051560" y="3246120"/>
+            <a:ext cx="10058400" cy="365760"/>
+          </a:xfrm>
+          <a:prstGeom prst="rect">
+            <a:avLst/>
+          </a:prstGeom>
+          <a:noFill/>
+          <a:ln/>
+        </p:spPr>
+        <p:txBody>
+          <a:bodyPr wrap="square" lIns="0" tIns="0" rIns="0" bIns="0" rtlCol="0" anchor="ctr"/>
+          <a:lstStyle/>
+          <a:p>
+            <a:pPr indent="0" marL="0">
+              <a:buNone/>
+            </a:pPr>
+            <a:r>
+              <a:rPr lang="en-US" sz="1500" b="1" dirty="0">
+                <a:solidFill>
+                  <a:srgbClr val="3F6F5F"/>
+                </a:solidFill>
+                <a:latin typeface="Calibri" pitchFamily="34" charset="0"/>
+                <a:ea typeface="Calibri" pitchFamily="34" charset="-122"/>
+                <a:cs typeface="Calibri" pitchFamily="34" charset="-120"/>
+              </a:rPr>
+              <a:t>Collect it for real</a:t>
+            </a:r>
+            <a:endParaRPr lang="en-US" sz="1500" dirty="0"/>
+          </a:p>
+        </p:txBody>
+      </p:sp>
+      <p:sp>
+        <p:nvSpPr>
+          <p:cNvPr id="9" name="Text 7"/>
+          <p:cNvSpPr/>
+          <p:nvPr/>
+        </p:nvSpPr>
+        <p:spPr>
+          <a:xfrm>
+            <a:off x="1051560" y="3611880"/>
+            <a:ext cx="9875520" cy="868680"/>
+          </a:xfrm>
+          <a:prstGeom prst="rect">
+            <a:avLst/>
+          </a:prstGeom>
+          <a:noFill/>
+          <a:ln/>
+        </p:spPr>
+        <p:txBody>
+          <a:bodyPr wrap="square" lIns="0" tIns="0" rIns="0" bIns="0" rtlCol="0" anchor="t"/>
+          <a:lstStyle/>
+          <a:p>
+            <a:pPr indent="0" marL="0">
+              <a:buNone/>
+            </a:pPr>
+            <a:r>
+              <a:rPr lang="en-US" sz="1400" dirty="0">
+                <a:solidFill>
+                  <a:srgbClr val="E8DCD6"/>
+                </a:solidFill>
+                <a:latin typeface="Calibri" pitchFamily="34" charset="0"/>
+                <a:ea typeface="Calibri" pitchFamily="34" charset="-122"/>
+                <a:cs typeface="Calibri" pitchFamily="34" charset="-120"/>
+              </a:rPr>
+              <a:t>The cookbook notebook, and leave the file in Drive. Week 5 begins there.</a:t>
+            </a:r>
+            <a:endParaRPr lang="en-US" sz="1400" dirty="0"/>
+          </a:p>
+        </p:txBody>
+      </p:sp>
+      <p:sp>
+        <p:nvSpPr>
+          <p:cNvPr id="10" name="Shape 8"/>
+          <p:cNvSpPr/>
+          <p:nvPr/>
+        </p:nvSpPr>
+        <p:spPr>
+          <a:xfrm>
+            <a:off x="640080" y="4709160"/>
+            <a:ext cx="219456" cy="219456"/>
+          </a:xfrm>
+          <a:prstGeom prst="ellipse">
+            <a:avLst/>
+          </a:prstGeom>
+          <a:solidFill>
+            <a:srgbClr val="E8DCD6"/>
+          </a:solidFill>
+          <a:ln/>
+        </p:spPr>
+      </p:sp>
+      <p:sp>
+        <p:nvSpPr>
+          <p:cNvPr id="11" name="Text 9"/>
+          <p:cNvSpPr/>
+          <p:nvPr/>
+        </p:nvSpPr>
+        <p:spPr>
+          <a:xfrm>
+            <a:off x="1051560" y="4572000"/>
+            <a:ext cx="10058400" cy="365760"/>
+          </a:xfrm>
+          <a:prstGeom prst="rect">
+            <a:avLst/>
+          </a:prstGeom>
+          <a:noFill/>
+          <a:ln/>
+        </p:spPr>
+        <p:txBody>
+          <a:bodyPr wrap="square" lIns="0" tIns="0" rIns="0" bIns="0" rtlCol="0" anchor="ctr"/>
+          <a:lstStyle/>
+          <a:p>
+            <a:pPr indent="0" marL="0">
+              <a:buNone/>
+            </a:pPr>
+            <a:r>
+              <a:rPr lang="en-US" sz="1500" b="1" dirty="0">
+                <a:solidFill>
+                  <a:srgbClr val="E8DCD6"/>
+                </a:solidFill>
+                <a:latin typeface="Calibri" pitchFamily="34" charset="0"/>
+                <a:ea typeface="Calibri" pitchFamily="34" charset="-122"/>
+                <a:cs typeface="Calibri" pitchFamily="34" charset="-120"/>
+              </a:rPr>
+              <a:t>Play with the map</a:t>
+            </a:r>
+            <a:endParaRPr lang="en-US" sz="1500" dirty="0"/>
+          </a:p>
+        </p:txBody>
+      </p:sp>
+      <p:sp>
+        <p:nvSpPr>
+          <p:cNvPr id="12" name="Text 10"/>
+          <p:cNvSpPr/>
+          <p:nvPr/>
+        </p:nvSpPr>
+        <p:spPr>
+          <a:xfrm>
+            <a:off x="1051560" y="4937760"/>
+            <a:ext cx="9875520" cy="868680"/>
+          </a:xfrm>
+          <a:prstGeom prst="rect">
+            <a:avLst/>
+          </a:prstGeom>
+          <a:noFill/>
+          <a:ln/>
+        </p:spPr>
+        <p:txBody>
+          <a:bodyPr wrap="square" lIns="0" tIns="0" rIns="0" bIns="0" rtlCol="0" anchor="t"/>
+          <a:lstStyle/>
+          <a:p>
+            <a:pPr indent="0" marL="0">
+              <a:buNone/>
+            </a:pPr>
+            <a:r>
+              <a:rPr lang="en-US" sz="1400" dirty="0">
+                <a:solidFill>
+                  <a:srgbClr val="E8DCD6"/>
+                </a:solidFill>
+                <a:latin typeface="Calibri" pitchFamily="34" charset="0"/>
+                <a:ea typeface="Calibri" pitchFamily="34" charset="-122"/>
+                <a:cs typeface="Calibri" pitchFamily="34" charset="-120"/>
+              </a:rPr>
+              <a:t>Embedding Projector: a word from your corpus, one neighbour that makes sense and one that does not.</a:t>
+            </a:r>
+            <a:endParaRPr lang="en-US" sz="1400" dirty="0"/>
+          </a:p>
+        </p:txBody>
+      </p:sp>
+      <p:sp>
+        <p:nvSpPr>
+          <p:cNvPr id="13" name="Text 11"/>
+          <p:cNvSpPr/>
+          <p:nvPr/>
+        </p:nvSpPr>
+        <p:spPr>
+          <a:xfrm>
+            <a:off x="640080" y="6035040"/>
+            <a:ext cx="10881360" cy="457200"/>
+          </a:xfrm>
+          <a:prstGeom prst="rect">
+            <a:avLst/>
+          </a:prstGeom>
+          <a:noFill/>
+          <a:ln/>
+        </p:spPr>
+        <p:txBody>
+          <a:bodyPr wrap="square" rtlCol="0" anchor="ctr"/>
+          <a:lstStyle/>
+          <a:p>
+            <a:pPr indent="0" marL="0">
+              <a:buNone/>
+            </a:pPr>
+            <a:r>
+              <a:rPr lang="en-US" sz="1300" i="1" dirty="0">
+                <a:solidFill>
+                  <a:srgbClr val="B9852F"/>
+                </a:solidFill>
+                <a:latin typeface="Calibri" pitchFamily="34" charset="0"/>
+                <a:ea typeface="Calibri" pitchFamily="34" charset="-122"/>
+                <a:cs typeface="Calibri" pitchFamily="34" charset="-120"/>
+              </a:rPr>
+              <a:t>Next week: embeddings on YOUR corpus, all session. Bring the file.</a:t>
+            </a:r>
+            <a:endParaRPr lang="en-US" sz="1300" dirty="0"/>
           </a:p>
         </p:txBody>
       </p:sp>

</xml_diff>

<commit_message>
Put Wittgenstein's line on the slide, not just in the footnote
"The meaning of a word is its use in the language" now sits under Firth's
line on the distributional slide, cited to Philosophical Investigations
§43. Both quotes open the notebook section too. Frege keeps one clause of
credit in the footer for getting there in 1884.

Co-Authored-By: Claude Opus 5 <noreply@anthropic.com>
Claude-Session: https://claude.ai/code/session_019zyD3od7wiSyuKJ3rsod35
</commit_message>
<xml_diff>
--- a/slides/week-04-lecture-draft.pptx
+++ b/slides/week-04-lecture-draft.pptx
@@ -4666,9 +4666,62 @@
           </a:p>
         </p:txBody>
       </p:sp>
+      <p:sp>
+        <p:nvSpPr>
+          <p:cNvPr id="4" name="Text 2"/>
+          <p:cNvSpPr/>
+          <p:nvPr/>
+        </p:nvSpPr>
+        <p:spPr>
+          <a:xfrm>
+            <a:off x="640080" y="1664208"/>
+            <a:ext cx="10881360" cy="365760"/>
+          </a:xfrm>
+          <a:prstGeom prst="rect">
+            <a:avLst/>
+          </a:prstGeom>
+          <a:noFill/>
+          <a:ln/>
+        </p:spPr>
+        <p:txBody>
+          <a:bodyPr wrap="square" rtlCol="0" anchor="ctr"/>
+          <a:lstStyle/>
+          <a:p>
+            <a:pPr indent="0" marL="0">
+              <a:buNone/>
+            </a:pPr>
+            <a:r>
+              <a:rPr lang="en-US" sz="1700" i="1" dirty="0">
+                <a:solidFill>
+                  <a:srgbClr val="7A3B2E"/>
+                </a:solidFill>
+                <a:latin typeface="Cambria" pitchFamily="34" charset="0"/>
+                <a:ea typeface="Cambria" pitchFamily="34" charset="-122"/>
+                <a:cs typeface="Cambria" pitchFamily="34" charset="-120"/>
+              </a:rPr>
+              <a:t>“The meaning of a word is its use in the language.”</a:t>
+            </a:r>
+            <a:pPr indent="0" marL="0">
+              <a:buNone/>
+            </a:pPr>
+            <a:r>
+              <a:rPr lang="en-US" sz="1300" dirty="0">
+                <a:solidFill>
+                  <a:srgbClr val="6B6B63"/>
+                </a:solidFill>
+                <a:latin typeface="Cambria" pitchFamily="34" charset="0"/>
+                <a:ea typeface="Cambria" pitchFamily="34" charset="-122"/>
+                <a:cs typeface="Cambria" pitchFamily="34" charset="-120"/>
+              </a:rPr>
+              <a:t>   Wittgenstein, Philosophical Investigations §43 (1953)</a:t>
+            </a:r>
+            <a:endParaRPr lang="en-US" sz="1700" dirty="0"/>
+          </a:p>
+        </p:txBody>
+      </p:sp>
       <p:pic>
         <p:nvPicPr>
-          <p:cNvPr id="4" name="Image 0" descr="/tmp/figs/w4_distributional.png">    </p:cNvPr>
+          <p:cNvPr id="5" name="Image 0" descr="/tmp/figs/w4_distributional.png">    </p:cNvPr>
           <p:cNvPicPr>
             <a:picLocks noChangeAspect="1"/>
           </p:cNvPicPr>
@@ -4681,8 +4734,8 @@
         </p:blipFill>
         <p:spPr>
           <a:xfrm>
-            <a:off x="914400" y="1874520"/>
-            <a:ext cx="10332720" cy="3566160"/>
+            <a:off x="914400" y="2148840"/>
+            <a:ext cx="10332720" cy="3291840"/>
           </a:xfrm>
           <a:prstGeom prst="rect">
             <a:avLst/>
@@ -4691,7 +4744,7 @@
       </p:pic>
       <p:sp>
         <p:nvSpPr>
-          <p:cNvPr id="5" name="Text 2"/>
+          <p:cNvPr id="6" name="Text 3"/>
           <p:cNvSpPr/>
           <p:nvPr/>
         </p:nvSpPr>
@@ -4730,7 +4783,7 @@
       </p:sp>
       <p:sp>
         <p:nvSpPr>
-          <p:cNvPr id="6" name="Text 3"/>
+          <p:cNvPr id="7" name="Text 4"/>
           <p:cNvSpPr/>
           <p:nvPr/>
         </p:nvSpPr>
@@ -4761,7 +4814,7 @@
                 <a:ea typeface="Calibri" pitchFamily="34" charset="-122"/>
                 <a:cs typeface="Calibri" pitchFamily="34" charset="-120"/>
               </a:rPr>
-              <a:t>Frege 1884, never ask for the meaning of a word in isolation · Wittgenstein 1953, the meaning of a word is its use · Harris 1954, the distributional hypothesis · Firth 1957, the line above. Lines drawn live from this week's corpus.</a:t>
+              <a:t>Frege 1884, never ask for the meaning of a word in isolation · Harris 1954, the distributional hypothesis · Firth 1957, the title. Lines drawn live from this week's corpus.</a:t>
             </a:r>
             <a:endParaRPr lang="en-US" sz="1000" dirty="0"/>
           </a:p>

</xml_diff>

<commit_message>
Cut the remaining flourishes from the notebook and the deck
Notebook: 39 edits across the markdown and the comments. Gone are the
aphoristic closers ("At scale, this is what lets you search an untagged
collection by typing"), the mannered qualifiers ("which is to say not at
all", "the only honest answer is", "now the selectors write themselves"),
and the restatements of the pull-and-push rule in three separate places.
Markdown is down to a 32-word median.

Deck: ten caption edits in the same direction, mostly breaking up
semicolon parallels and trimming footers.

Co-Authored-By: Claude Opus 5 <noreply@anthropic.com>
Claude-Session: https://claude.ai/code/session_019zyD3od7wiSyuKJ3rsod35
</commit_message>
<xml_diff>
--- a/slides/week-04-lecture-draft.pptx
+++ b/slides/week-04-lecture-draft.pptx
@@ -4775,7 +4775,7 @@
                 <a:ea typeface="Cambria" pitchFamily="34" charset="-122"/>
                 <a:cs typeface="Cambria" pitchFamily="34" charset="-120"/>
               </a:rPr>
-              <a:t>Ask the room before you show the answer. Nobody needs a definition of the word; the contexts are enough.</a:t>
+              <a:t>Ask the room before you show the answer. Nobody needs a definition. The contexts are enough.</a:t>
             </a:r>
             <a:endParaRPr lang="en-US" sz="1600" dirty="0"/>
           </a:p>
@@ -5025,7 +5025,7 @@
                 <a:ea typeface="Calibri" pitchFamily="34" charset="-122"/>
                 <a:cs typeface="Calibri" pitchFamily="34" charset="-120"/>
               </a:rPr>
-              <a:t>Underneath it, Week 3's four moves: multiply, add, squash, nudge. The difference is that the prediction is thrown away and the weights are what you keep. 849,738 pairs in one pass.</a:t>
+              <a:t>Underneath it, Week 3's four moves: multiply, add, squash, nudge. The prediction gets thrown away; the weights are what you keep. 849,738 pairs in one pass.</a:t>
             </a:r>
             <a:endParaRPr lang="en-US" sz="1000" dirty="0"/>
           </a:p>
@@ -5369,7 +5369,7 @@
                 <a:ea typeface="Cambria" pitchFamily="34" charset="-122"/>
                 <a:cs typeface="Cambria" pitchFamily="34" charset="-120"/>
               </a:rPr>
-              <a:t>225,355 words of Frankenstein and Dracula, and no labels anywhere. Nobody told it what a door is.</a:t>
+              <a:t>225,355 words of Frankenstein and Dracula. Nobody told it what a door is.</a:t>
             </a:r>
             <a:endParaRPr lang="en-US" sz="1600" dirty="0"/>
           </a:p>
@@ -5752,7 +5752,7 @@
                 <a:ea typeface="Cambria" pitchFamily="34" charset="-122"/>
                 <a:cs typeface="Cambria" pitchFamily="34" charset="-120"/>
               </a:rPr>
-              <a:t>Nobody labelled any of this. It is what a century of printed English put near what.</a:t>
+              <a:t>Nobody labelled any of this. It is only what a century of printed English put side by side.</a:t>
             </a:r>
             <a:endParaRPr lang="en-US" sz="1600" dirty="0"/>
           </a:p>
@@ -8009,7 +8009,7 @@
                 <a:ea typeface="Calibri" pitchFamily="34" charset="-122"/>
                 <a:cs typeface="Calibri" pitchFamily="34" charset="-120"/>
               </a:rPr>
-              <a:t>Every panel is real arithmetic on the painting to its left. Stacking them is all a CNN is.</a:t>
+              <a:t>Every panel is real arithmetic on the painting to its left. Stacking them is what a CNN does.</a:t>
             </a:r>
             <a:endParaRPr lang="en-US" sz="1000" dirty="0"/>
           </a:p>
@@ -8220,7 +8220,7 @@
                 <a:ea typeface="Calibri" pitchFamily="34" charset="-122"/>
                 <a:cs typeface="Calibri" pitchFamily="34" charset="-120"/>
               </a:rPr>
-              <a:t>Which is why "a painting of a woman in a red hat" can search a museum with no tags in it at all. The notebook trains a small one on 18 paintings.</a:t>
+              <a:t>Which is why "a painting of a woman in a red hat" can search a museum with no tags in it. The notebook trains a small one on 18 paintings.</a:t>
             </a:r>
             <a:endParaRPr lang="en-US" sz="1000" dirty="0"/>
           </a:p>
@@ -9628,7 +9628,7 @@
                 <a:ea typeface="Calibri" pitchFamily="34" charset="-122"/>
                 <a:cs typeface="Calibri" pitchFamily="34" charset="-120"/>
               </a:rPr>
-              <a:t>Both queried live for this slide. Work out which kind you have before you estimate how long anything will take.</a:t>
+              <a:t>Both queried live for this slide. Work out which kind you have before you estimate how long it takes.</a:t>
             </a:r>
             <a:endParaRPr lang="en-US" sz="1000" dirty="0"/>
           </a:p>
@@ -10599,7 +10599,7 @@
                 <a:ea typeface="Calibri" pitchFamily="34" charset="-122"/>
                 <a:cs typeface="Calibri" pitchFamily="34" charset="-120"/>
               </a:rPr>
-              <a:t>Real HTML from quotes.toscrape.com. A selector that matches nothing returns None and raises no error, which is the bug you will actually hit.</a:t>
+              <a:t>Real HTML from quotes.toscrape.com. A selector that matches nothing returns None and raises no error. That is the bug you will hit.</a:t>
             </a:r>
             <a:endParaRPr lang="en-US" sz="1000" dirty="0"/>
           </a:p>
@@ -10810,7 +10810,7 @@
                 <a:ea typeface="Calibri" pitchFamily="34" charset="-122"/>
                 <a:cs typeface="Calibri" pitchFamily="34" charset="-120"/>
               </a:rPr>
-              <a:t>And the site notices the difference. One page a second is a reader; fifty a second is an outage.</a:t>
+              <a:t>One page a second is a reader. Fifty a second is an outage.</a:t>
             </a:r>
             <a:endParaRPr lang="en-US" sz="1000" dirty="0"/>
           </a:p>
@@ -13074,7 +13074,7 @@
                 <a:ea typeface="Cambria" pitchFamily="34" charset="-122"/>
                 <a:cs typeface="Cambria" pitchFamily="34" charset="-120"/>
               </a:rPr>
-              <a:t>Same passages, same job: 100% against 99%. You can read the left panel and say why. You cannot do that with the right one.</a:t>
+              <a:t>Same passages, same job: 100% against 99%. You can read the left panel. You cannot read the right one.</a:t>
             </a:r>
             <a:endParaRPr lang="en-US" sz="1600" dirty="0"/>
           </a:p>

</xml_diff>

<commit_message>
Plainer wording again, in the notebook and the deck
Shorter sentences and ordinary words. "In a bag of words, every word gets
its own column. Nothing connects one column to another." "Week 3 kept the
prediction. Here we throw the prediction away and keep the weights." The
notebook's markdown now averages ten words a sentence.

Also removed the last of the vague slide titles: "Stack them and
something changes" now says what changes.

Co-Authored-By: Claude Opus 5 <noreply@anthropic.com>
Claude-Session: https://claude.ai/code/session_019zyD3od7wiSyuKJ3rsod35
</commit_message>
<xml_diff>
--- a/slides/week-04-lecture-draft.pptx
+++ b/slides/week-04-lecture-draft.pptx
@@ -3876,7 +3876,7 @@
                 <a:ea typeface="Calibri" pitchFamily="34" charset="-122"/>
                 <a:cs typeface="Calibri" pitchFamily="34" charset="-120"/>
               </a:rPr>
-              <a:t>Your Week 3 classifier is one neuron. Today it grows, learns a map of meaning,</a:t>
+              <a:t>Your Week 3 classifier is one neuron. Today it grows, learns to place words by the</a:t>
             </a:r>
             <a:endParaRPr lang="en-US" sz="1700" dirty="0"/>
           </a:p>
@@ -3896,7 +3896,7 @@
                 <a:ea typeface="Calibri" pitchFamily="34" charset="-122"/>
                 <a:cs typeface="Calibri" pitchFamily="34" charset="-120"/>
               </a:rPr>
-              <a:t>and then you go and fetch the data you will use it on</a:t>
+              <a:t>company they keep, and then you go and collect the data you will use it on</a:t>
             </a:r>
             <a:endParaRPr lang="en-US" sz="1700" dirty="0"/>
           </a:p>
@@ -4339,7 +4339,7 @@
                 <a:ea typeface="Cambria" pitchFamily="34" charset="-122"/>
                 <a:cs typeface="Cambria" pitchFamily="34" charset="-120"/>
               </a:rPr>
-              <a:t>A loss says how wrong you are. Step downhill, repeat, thousands of weights at once. No calculus today.</a:t>
+              <a:t>A loss is one number saying how wrong you are. Step downhill, repeat, for thousands of weights at once. No calculus today.</a:t>
             </a:r>
             <a:endParaRPr lang="en-US" sz="1600" dirty="0"/>
           </a:p>
@@ -5580,7 +5580,7 @@
                 <a:ea typeface="Calibri" pitchFamily="34" charset="-122"/>
                 <a:cs typeface="Calibri" pitchFamily="34" charset="-120"/>
               </a:rPr>
-              <a:t>Two dimensions of sixty; the picture always loses something. Next: the Embedding Projector, live.</a:t>
+              <a:t>Two dimensions out of sixty, so the picture loses a lot. Next: the Embedding Projector, live.</a:t>
             </a:r>
             <a:endParaRPr lang="en-US" sz="1000" dirty="0"/>
           </a:p>
@@ -5752,7 +5752,7 @@
                 <a:ea typeface="Cambria" pitchFamily="34" charset="-122"/>
                 <a:cs typeface="Cambria" pitchFamily="34" charset="-120"/>
               </a:rPr>
-              <a:t>Nobody labelled any of this. It is only what a century of printed English put side by side.</a:t>
+              <a:t>Nobody labelled any of this. It is what a century of printed English put side by side.</a:t>
             </a:r>
             <a:endParaRPr lang="en-US" sz="1600" dirty="0"/>
           </a:p>
@@ -6740,7 +6740,7 @@
                 <a:ea typeface="Calibri" pitchFamily="34" charset="-122"/>
                 <a:cs typeface="Calibri" pitchFamily="34" charset="-120"/>
               </a:rPr>
-              <a:t>Your classifier, stacked - and what stacking buys and costs</a:t>
+              <a:t>Your classifier, stacked, and what that gains and costs</a:t>
             </a:r>
             <a:endParaRPr lang="en-US" sz="1250" dirty="0"/>
           </a:p>
@@ -8220,7 +8220,7 @@
                 <a:ea typeface="Calibri" pitchFamily="34" charset="-122"/>
                 <a:cs typeface="Calibri" pitchFamily="34" charset="-120"/>
               </a:rPr>
-              <a:t>Which is why "a painting of a woman in a red hat" can search a museum with no tags in it. The notebook trains a small one on 18 paintings.</a:t>
+              <a:t>This is why you can search an untagged museum by typing "a woman in a red hat". The notebook trains a small one on 18 paintings.</a:t>
             </a:r>
             <a:endParaRPr lang="en-US" sz="1000" dirty="0"/>
           </a:p>
@@ -9167,7 +9167,7 @@
                 <a:ea typeface="Cambria" pitchFamily="34" charset="-122"/>
                 <a:cs typeface="Cambria" pitchFamily="34" charset="-120"/>
               </a:rPr>
-              <a:t>Ask for one item. The pagination block tells you how big the job is; the data block is your rows.</a:t>
+              <a:t>Ask for one item. The pagination block tells you how big the job is. The data block is your rows.</a:t>
             </a:r>
             <a:endParaRPr lang="en-US" sz="1600" dirty="0"/>
           </a:p>
@@ -9589,7 +9589,7 @@
                 <a:ea typeface="Cambria" pitchFamily="34" charset="-122"/>
                 <a:cs typeface="Cambria" pitchFamily="34" charset="-120"/>
               </a:rPr>
-              <a:t>One hands you rows. The other hands you a phone book, and every row after that is another request.</a:t>
+              <a:t>One returns rows. The other returns ID numbers, and every row after that is another request.</a:t>
             </a:r>
             <a:endParaRPr lang="en-US" sz="1600" dirty="0"/>
           </a:p>
@@ -10560,7 +10560,7 @@
                 <a:ea typeface="Cambria" pitchFamily="34" charset="-122"/>
                 <a:cs typeface="Cambria" pitchFamily="34" charset="-120"/>
               </a:rPr>
-              <a:t>Fetch one page, look at one block, and read the selectors off it. Right-click, Inspect, and the tag names are right there.</a:t>
+              <a:t>Fetch one page, look at one block, and read the selectors off it. In a browser: right-click, Inspect, and the tag names are there.</a:t>
             </a:r>
             <a:endParaRPr lang="en-US" sz="1600" dirty="0"/>
           </a:p>
@@ -12840,7 +12840,7 @@
                 <a:ea typeface="Cambria" pitchFamily="34" charset="-122"/>
                 <a:cs typeface="Cambria" pitchFamily="34" charset="-120"/>
               </a:rPr>
-              <a:t>Stack them and something changes</a:t>
+              <a:t>Stack them and they learn combinations</a:t>
             </a:r>
             <a:endParaRPr lang="en-US" sz="3400" dirty="0"/>
           </a:p>

</xml_diff>

<commit_message>
Replace the spiral with a demo about meaning
The spiral showed that a line has limits, but it was an abstract shape. In
its place: the same 13,915 words rated for valence and arousal, asked two
questions.

Is it pleasant? That is a direction, and logistic regression gets 100%.
The network adds nothing.

Is it emotionally charged, either way? That is a distance from the middle,
so the positive class sits at both ends. The line drops to 68%. A small
network gets 100%, because it can draw two boundaries instead of one.

The dimensions are Osgood's evaluation and activity, re-measured by
Warriner, Kuperman and Brysbaert (2013) and fetched at build time rather
than stored. The lecture and the week page now point at Playground's XOR
set, which has the same shape as the second question.

Co-Authored-By: Claude Opus 5 <noreply@anthropic.com>
Claude-Session: https://claude.ai/code/session_019zyD3od7wiSyuKJ3rsod35
</commit_message>
<xml_diff>
--- a/slides/week-04-lecture-draft.pptx
+++ b/slides/week-04-lecture-draft.pptx
@@ -4027,7 +4027,7 @@
                 <a:ea typeface="Calibri" pitchFamily="34" charset="-122"/>
                 <a:cs typeface="Calibri" pitchFamily="34" charset="-120"/>
               </a:rPr>
-              <a:t>WHY IT MATTERS</a:t>
+              <a:t>WHEN YOU NEED THE EXTRA LAYER</a:t>
             </a:r>
             <a:endParaRPr lang="en-US" sz="1300" dirty="0"/>
           </a:p>
@@ -4066,7 +4066,7 @@
                 <a:ea typeface="Cambria" pitchFamily="34" charset="-122"/>
                 <a:cs typeface="Cambria" pitchFamily="34" charset="-120"/>
               </a:rPr>
-              <a:t>Some questions a straight line cannot answer</a:t>
+              <a:t>One question a line can answer, one it cannot</a:t>
             </a:r>
             <a:endParaRPr lang="en-US" sz="3400" dirty="0"/>
           </a:p>
@@ -4074,7 +4074,7 @@
       </p:sp>
       <p:pic>
         <p:nvPicPr>
-          <p:cNvPr id="4" name="Image 0" descr="/tmp/figs/w4_spiral.png">    </p:cNvPr>
+          <p:cNvPr id="4" name="Image 0" descr="/tmp/figs/w4_meaning.png">    </p:cNvPr>
           <p:cNvPicPr>
             <a:picLocks noChangeAspect="1"/>
           </p:cNvPicPr>
@@ -4087,8 +4087,8 @@
         </p:blipFill>
         <p:spPr>
           <a:xfrm>
-            <a:off x="1097280" y="1737360"/>
-            <a:ext cx="9966960" cy="4114800"/>
+            <a:off x="548640" y="1828800"/>
+            <a:ext cx="11064240" cy="3657600"/>
           </a:xfrm>
           <a:prstGeom prst="rect">
             <a:avLst/>
@@ -4128,7 +4128,7 @@
                 <a:ea typeface="Cambria" pitchFamily="34" charset="-122"/>
                 <a:cs typeface="Cambria" pitchFamily="34" charset="-120"/>
               </a:rPr>
-              <a:t>Same points, same training. One neuron: 70%. Two hidden layers: 99%.</a:t>
+              <a:t>"Which side?" is a direction: a line gets 100%. "How far from the middle?" is a distance: 68% for the line, 100% for the network.</a:t>
             </a:r>
             <a:endParaRPr lang="en-US" sz="1600" dirty="0"/>
           </a:p>
@@ -4167,7 +4167,7 @@
                 <a:ea typeface="Calibri" pitchFamily="34" charset="-122"/>
                 <a:cs typeface="Calibri" pitchFamily="34" charset="-120"/>
               </a:rPr>
-              <a:t>Both models fitted for this slide. Next: the same thing live in TensorFlow Playground.</a:t>
+              <a:t>Valence and arousal for 13,915 words, Warriner, Kuperman &amp; Brysbaert (2013), fetched at build time. Osgood's dimensions, measured again. Next: Playground on the XOR set.</a:t>
             </a:r>
             <a:endParaRPr lang="en-US" sz="1000" dirty="0"/>
           </a:p>
@@ -4986,7 +4986,7 @@
                 <a:ea typeface="Cambria" pitchFamily="34" charset="-122"/>
                 <a:cs typeface="Cambria" pitchFamily="34" charset="-120"/>
               </a:rPr>
-              <a:t>For a word, a context is a few words of text. That is the whole rule. It is called contrastive learning, and most modern embeddings are trained this way.</a:t>
+              <a:t>For a word, a context is a few words of text. That is the whole rule, and it is how most modern embeddings are trained.</a:t>
             </a:r>
             <a:endParaRPr lang="en-US" sz="1600" dirty="0"/>
           </a:p>

</xml_diff>